<commit_message>
Set L01 NTU-web body & code to 17pt; resize slide-7 code block
Per learner feedback, raise all body and code text to 17pt for projector
legibility, and grow slide 7's code panel (h 3.8 -> 4.7) so the 13-line
Python snippet renders without clipping. Trailing question callout moved
to the slide footer at a smaller 13pt so it doesn't push off the slide.

Co-Authored-By: Claude Opus 4.7 <noreply@anthropic.com>
</commit_message>
<xml_diff>
--- a/L01-intro-ml/slides/L01_slides_ntu_web.pptx
+++ b/L01-intro-ml/slides/L01_slides_ntu_web.pptx
@@ -2835,7 +2835,7 @@
               <a:buNone/>
             </a:pPr>
             <a:r>
-              <a:rPr lang="en-US" sz="1400" b="1" spc="400" kern="0" dirty="0">
+              <a:rPr lang="en-US" sz="1700" b="1" spc="400" kern="0" dirty="0">
                 <a:solidFill>
                   <a:srgbClr val="C8102E"/>
                 </a:solidFill>
@@ -2845,7 +2845,7 @@
               </a:rPr>
               <a:t>Module 3  ·  Machine Learning &amp; GenAI</a:t>
             </a:r>
-            <a:endParaRPr lang="en-US" sz="1400" dirty="0"/>
+            <a:endParaRPr lang="en-US" sz="1700" dirty="0"/>
           </a:p>
         </p:txBody>
       </p:sp>
@@ -3106,7 +3106,7 @@
               <a:buNone/>
             </a:pPr>
             <a:r>
-              <a:rPr lang="en-US" sz="1600" b="1" dirty="0">
+              <a:rPr lang="en-US" sz="1700" b="1" dirty="0">
                 <a:solidFill>
                   <a:srgbClr val="FFFFFF"/>
                 </a:solidFill>
@@ -3116,7 +3116,7 @@
               </a:rPr>
               <a:t>Pre-trained Models</a:t>
             </a:r>
-            <a:endParaRPr lang="en-US" sz="1600" dirty="0"/>
+            <a:endParaRPr lang="en-US" sz="1700" dirty="0"/>
           </a:p>
         </p:txBody>
       </p:sp>
@@ -3378,7 +3378,7 @@
               <a:buNone/>
             </a:pPr>
             <a:r>
-              <a:rPr lang="en-US" sz="1600" i="1" dirty="0">
+              <a:rPr lang="en-US" sz="1700" i="1" dirty="0">
                 <a:solidFill>
                   <a:srgbClr val="1B2A4A"/>
                 </a:solidFill>
@@ -3392,7 +3392,7 @@
               <a:buNone/>
             </a:pPr>
             <a:r>
-              <a:rPr lang="en-US" sz="1600" b="1" i="1" dirty="0">
+              <a:rPr lang="en-US" sz="1700" b="1" i="1" dirty="0">
                 <a:solidFill>
                   <a:srgbClr val="C8102E"/>
                 </a:solidFill>
@@ -3406,7 +3406,7 @@
               <a:buNone/>
             </a:pPr>
             <a:r>
-              <a:rPr lang="en-US" sz="1600" i="1" dirty="0">
+              <a:rPr lang="en-US" sz="1700" i="1" dirty="0">
                 <a:solidFill>
                   <a:srgbClr val="1B2A4A"/>
                 </a:solidFill>
@@ -3416,7 +3416,7 @@
               </a:rPr>
               <a:t>  Load it. Use it. Don't train from scratch unless your task is genuinely unique.</a:t>
             </a:r>
-            <a:endParaRPr lang="en-US" sz="1600" dirty="0"/>
+            <a:endParaRPr lang="en-US" sz="1700" dirty="0"/>
           </a:p>
         </p:txBody>
       </p:sp>
@@ -3537,7 +3537,7 @@
               <a:buNone/>
             </a:pPr>
             <a:r>
-              <a:rPr lang="en-US" sz="1500" dirty="0">
+              <a:rPr lang="en-US" sz="1700" dirty="0">
                 <a:solidFill>
                   <a:srgbClr val="333D4D"/>
                 </a:solidFill>
@@ -3547,7 +3547,7 @@
               </a:rPr>
               <a:t>•  Hugging Face — open repository (hundreds of models)</a:t>
             </a:r>
-            <a:endParaRPr lang="en-US" sz="1500" dirty="0"/>
+            <a:endParaRPr lang="en-US" sz="1700" dirty="0"/>
           </a:p>
           <a:p>
             <a:pPr indent="0" marL="0">
@@ -3557,7 +3557,7 @@
               <a:buNone/>
             </a:pPr>
             <a:r>
-              <a:rPr lang="en-US" sz="1500" dirty="0">
+              <a:rPr lang="en-US" sz="1700" dirty="0">
                 <a:solidFill>
                   <a:srgbClr val="333D4D"/>
                 </a:solidFill>
@@ -3567,7 +3567,7 @@
               </a:rPr>
               <a:t>•  OpenAI, Anthropic, Google — large hosted models</a:t>
             </a:r>
-            <a:endParaRPr lang="en-US" sz="1500" dirty="0"/>
+            <a:endParaRPr lang="en-US" sz="1700" dirty="0"/>
           </a:p>
           <a:p>
             <a:pPr indent="0" marL="0">
@@ -3577,7 +3577,7 @@
               <a:buNone/>
             </a:pPr>
             <a:r>
-              <a:rPr lang="en-US" sz="1500" dirty="0">
+              <a:rPr lang="en-US" sz="1700" dirty="0">
                 <a:solidFill>
                   <a:srgbClr val="333D4D"/>
                 </a:solidFill>
@@ -3587,7 +3587,7 @@
               </a:rPr>
               <a:t>•  Industry-specific repos (medical, legal, finance)</a:t>
             </a:r>
-            <a:endParaRPr lang="en-US" sz="1500" dirty="0"/>
+            <a:endParaRPr lang="en-US" sz="1700" dirty="0"/>
           </a:p>
           <a:p>
             <a:pPr indent="0" marL="0">
@@ -3597,7 +3597,7 @@
               <a:buNone/>
             </a:pPr>
             <a:r>
-              <a:rPr lang="en-US" sz="1500" dirty="0">
+              <a:rPr lang="en-US" sz="1700" dirty="0">
                 <a:solidFill>
                   <a:srgbClr val="333D4D"/>
                 </a:solidFill>
@@ -3607,7 +3607,7 @@
               </a:rPr>
               <a:t>•  Research labs — published with each new paper</a:t>
             </a:r>
-            <a:endParaRPr lang="en-US" sz="1500" dirty="0"/>
+            <a:endParaRPr lang="en-US" sz="1700" dirty="0"/>
           </a:p>
         </p:txBody>
       </p:sp>
@@ -3728,7 +3728,7 @@
               <a:buNone/>
             </a:pPr>
             <a:r>
-              <a:rPr lang="en-US" sz="1500" dirty="0">
+              <a:rPr lang="en-US" sz="1700" dirty="0">
                 <a:solidFill>
                   <a:srgbClr val="333D4D"/>
                 </a:solidFill>
@@ -3738,7 +3738,7 @@
               </a:rPr>
               <a:t>✓  A POSITIVE / NEGATIVE label for every review</a:t>
             </a:r>
-            <a:endParaRPr lang="en-US" sz="1500" dirty="0"/>
+            <a:endParaRPr lang="en-US" sz="1700" dirty="0"/>
           </a:p>
           <a:p>
             <a:pPr indent="0" marL="0">
@@ -3748,7 +3748,7 @@
               <a:buNone/>
             </a:pPr>
             <a:r>
-              <a:rPr lang="en-US" sz="1500" dirty="0">
+              <a:rPr lang="en-US" sz="1700" dirty="0">
                 <a:solidFill>
                   <a:srgbClr val="333D4D"/>
                 </a:solidFill>
@@ -3758,7 +3758,7 @@
               </a:rPr>
               <a:t>✓  A confidence score (e.g. 97% POSITIVE)</a:t>
             </a:r>
-            <a:endParaRPr lang="en-US" sz="1500" dirty="0"/>
+            <a:endParaRPr lang="en-US" sz="1700" dirty="0"/>
           </a:p>
           <a:p>
             <a:pPr indent="0" marL="0">
@@ -3768,7 +3768,7 @@
               <a:buNone/>
             </a:pPr>
             <a:r>
-              <a:rPr lang="en-US" sz="1500" dirty="0">
+              <a:rPr lang="en-US" sz="1700" dirty="0">
                 <a:solidFill>
                   <a:srgbClr val="333D4D"/>
                 </a:solidFill>
@@ -3778,7 +3778,7 @@
               </a:rPr>
               <a:t>✓  Can filter to ‘NEGATIVE with &gt;90% confidence’</a:t>
             </a:r>
-            <a:endParaRPr lang="en-US" sz="1500" dirty="0"/>
+            <a:endParaRPr lang="en-US" sz="1700" dirty="0"/>
           </a:p>
           <a:p>
             <a:pPr indent="0" marL="0">
@@ -3788,7 +3788,7 @@
               <a:buNone/>
             </a:pPr>
             <a:r>
-              <a:rPr lang="en-US" sz="1500" dirty="0">
+              <a:rPr lang="en-US" sz="1700" dirty="0">
                 <a:solidFill>
                   <a:srgbClr val="333D4D"/>
                 </a:solidFill>
@@ -3798,7 +3798,7 @@
               </a:rPr>
               <a:t>✓  Runs in minutes — not a workweek</a:t>
             </a:r>
-            <a:endParaRPr lang="en-US" sz="1500" dirty="0"/>
+            <a:endParaRPr lang="en-US" sz="1700" dirty="0"/>
           </a:p>
         </p:txBody>
       </p:sp>
@@ -4135,7 +4135,7 @@
               <a:buNone/>
             </a:pPr>
             <a:r>
-              <a:rPr lang="en-US" sz="1400" b="1" dirty="0">
+              <a:rPr lang="en-US" sz="1700" b="1" dirty="0">
                 <a:solidFill>
                   <a:srgbClr val="FFFFFF"/>
                 </a:solidFill>
@@ -4145,7 +4145,7 @@
               </a:rPr>
               <a:t>1</a:t>
             </a:r>
-            <a:endParaRPr lang="en-US" sz="1400" dirty="0"/>
+            <a:endParaRPr lang="en-US" sz="1700" dirty="0"/>
           </a:p>
         </p:txBody>
       </p:sp>
@@ -4240,7 +4240,7 @@
               <a:buNone/>
             </a:pPr>
             <a:r>
-              <a:rPr lang="en-US" sz="1400" b="1" dirty="0">
+              <a:rPr lang="en-US" sz="1700" b="1" dirty="0">
                 <a:solidFill>
                   <a:srgbClr val="FFFFFF"/>
                 </a:solidFill>
@@ -4250,7 +4250,7 @@
               </a:rPr>
               <a:t>2</a:t>
             </a:r>
-            <a:endParaRPr lang="en-US" sz="1400" dirty="0"/>
+            <a:endParaRPr lang="en-US" sz="1700" dirty="0"/>
           </a:p>
         </p:txBody>
       </p:sp>
@@ -4345,7 +4345,7 @@
               <a:buNone/>
             </a:pPr>
             <a:r>
-              <a:rPr lang="en-US" sz="1400" b="1" dirty="0">
+              <a:rPr lang="en-US" sz="1700" b="1" dirty="0">
                 <a:solidFill>
                   <a:srgbClr val="FFFFFF"/>
                 </a:solidFill>
@@ -4355,7 +4355,7 @@
               </a:rPr>
               <a:t>3</a:t>
             </a:r>
-            <a:endParaRPr lang="en-US" sz="1400" dirty="0"/>
+            <a:endParaRPr lang="en-US" sz="1700" dirty="0"/>
           </a:p>
         </p:txBody>
       </p:sp>
@@ -4503,7 +4503,7 @@
               <a:buNone/>
             </a:pPr>
             <a:r>
-              <a:rPr lang="en-US" sz="1400" dirty="0">
+              <a:rPr lang="en-US" sz="1700" dirty="0">
                 <a:solidFill>
                   <a:srgbClr val="FFFFFF">
                     <a:alpha val="70000"/>
@@ -4601,7 +4601,7 @@
               <a:buNone/>
             </a:pPr>
             <a:r>
-              <a:rPr lang="en-US" sz="1600" b="1" dirty="0">
+              <a:rPr lang="en-US" sz="1700" b="1" dirty="0">
                 <a:solidFill>
                   <a:srgbClr val="FFFFFF"/>
                 </a:solidFill>
@@ -4611,7 +4611,7 @@
               </a:rPr>
               <a:t>Category 1: Supervised Learning</a:t>
             </a:r>
-            <a:endParaRPr lang="en-US" sz="1600" dirty="0"/>
+            <a:endParaRPr lang="en-US" sz="1700" dirty="0"/>
           </a:p>
         </p:txBody>
       </p:sp>
@@ -4770,7 +4770,7 @@
               <a:buNone/>
             </a:pPr>
             <a:r>
-              <a:rPr lang="en-US" sz="1400" b="1" spc="400" kern="0" dirty="0">
+              <a:rPr lang="en-US" sz="1700" b="1" spc="400" kern="0" dirty="0">
                 <a:solidFill>
                   <a:srgbClr val="FFFFFF"/>
                 </a:solidFill>
@@ -4780,7 +4780,7 @@
               </a:rPr>
               <a:t>#1</a:t>
             </a:r>
-            <a:endParaRPr lang="en-US" sz="1400" dirty="0"/>
+            <a:endParaRPr lang="en-US" sz="1700" dirty="0"/>
           </a:p>
         </p:txBody>
       </p:sp>
@@ -5065,7 +5065,7 @@
               <a:buNone/>
             </a:pPr>
             <a:r>
-              <a:rPr lang="en-US" sz="1500" dirty="0">
+              <a:rPr lang="en-US" sz="1700" dirty="0">
                 <a:solidFill>
                   <a:srgbClr val="333D4D"/>
                 </a:solidFill>
@@ -5075,7 +5075,7 @@
               </a:rPr>
               <a:t>A student studying past exam papers with answer keys. Many questions, many correct answers. Over time the student learns the patterns and can answer new questions on their own.</a:t>
             </a:r>
-            <a:endParaRPr lang="en-US" sz="1500" dirty="0"/>
+            <a:endParaRPr lang="en-US" sz="1700" dirty="0"/>
           </a:p>
         </p:txBody>
       </p:sp>
@@ -5196,7 +5196,7 @@
               <a:buNone/>
             </a:pPr>
             <a:r>
-              <a:rPr lang="en-US" sz="1500" dirty="0">
+              <a:rPr lang="en-US" sz="1700" dirty="0">
                 <a:solidFill>
                   <a:srgbClr val="333D4D"/>
                 </a:solidFill>
@@ -5206,7 +5206,7 @@
               </a:rPr>
               <a:t>•  Churn prediction</a:t>
             </a:r>
-            <a:endParaRPr lang="en-US" sz="1500" dirty="0"/>
+            <a:endParaRPr lang="en-US" sz="1700" dirty="0"/>
           </a:p>
           <a:p>
             <a:pPr indent="0" marL="0">
@@ -5216,7 +5216,7 @@
               <a:buNone/>
             </a:pPr>
             <a:r>
-              <a:rPr lang="en-US" sz="1500" dirty="0">
+              <a:rPr lang="en-US" sz="1700" dirty="0">
                 <a:solidFill>
                   <a:srgbClr val="333D4D"/>
                 </a:solidFill>
@@ -5226,7 +5226,7 @@
               </a:rPr>
               <a:t>•  Fraud detection</a:t>
             </a:r>
-            <a:endParaRPr lang="en-US" sz="1500" dirty="0"/>
+            <a:endParaRPr lang="en-US" sz="1700" dirty="0"/>
           </a:p>
           <a:p>
             <a:pPr indent="0" marL="0">
@@ -5236,7 +5236,7 @@
               <a:buNone/>
             </a:pPr>
             <a:r>
-              <a:rPr lang="en-US" sz="1500" dirty="0">
+              <a:rPr lang="en-US" sz="1700" dirty="0">
                 <a:solidFill>
                   <a:srgbClr val="333D4D"/>
                 </a:solidFill>
@@ -5246,7 +5246,7 @@
               </a:rPr>
               <a:t>•  Demand forecasting</a:t>
             </a:r>
-            <a:endParaRPr lang="en-US" sz="1500" dirty="0"/>
+            <a:endParaRPr lang="en-US" sz="1700" dirty="0"/>
           </a:p>
           <a:p>
             <a:pPr indent="0" marL="0">
@@ -5256,7 +5256,7 @@
               <a:buNone/>
             </a:pPr>
             <a:r>
-              <a:rPr lang="en-US" sz="1500" dirty="0">
+              <a:rPr lang="en-US" sz="1700" dirty="0">
                 <a:solidFill>
                   <a:srgbClr val="333D4D"/>
                 </a:solidFill>
@@ -5266,7 +5266,7 @@
               </a:rPr>
               <a:t>•  Sentiment / text classification</a:t>
             </a:r>
-            <a:endParaRPr lang="en-US" sz="1500" dirty="0"/>
+            <a:endParaRPr lang="en-US" sz="1700" dirty="0"/>
           </a:p>
           <a:p>
             <a:pPr indent="0" marL="0">
@@ -5276,7 +5276,7 @@
               <a:buNone/>
             </a:pPr>
             <a:r>
-              <a:rPr lang="en-US" sz="1500" dirty="0">
+              <a:rPr lang="en-US" sz="1700" dirty="0">
                 <a:solidFill>
                   <a:srgbClr val="333D4D"/>
                 </a:solidFill>
@@ -5286,7 +5286,7 @@
               </a:rPr>
               <a:t>•  Medical risk scoring</a:t>
             </a:r>
-            <a:endParaRPr lang="en-US" sz="1500" dirty="0"/>
+            <a:endParaRPr lang="en-US" sz="1700" dirty="0"/>
           </a:p>
           <a:p>
             <a:pPr indent="0" marL="0">
@@ -5296,7 +5296,7 @@
               <a:buNone/>
             </a:pPr>
             <a:r>
-              <a:rPr lang="en-US" sz="1500" dirty="0">
+              <a:rPr lang="en-US" sz="1700" dirty="0">
                 <a:solidFill>
                   <a:srgbClr val="333D4D"/>
                 </a:solidFill>
@@ -5306,7 +5306,7 @@
               </a:rPr>
               <a:t>•  Image labelling (cat vs dog)</a:t>
             </a:r>
-            <a:endParaRPr lang="en-US" sz="1500" dirty="0"/>
+            <a:endParaRPr lang="en-US" sz="1700" dirty="0"/>
           </a:p>
         </p:txBody>
       </p:sp>
@@ -5392,7 +5392,7 @@
               <a:buNone/>
             </a:pPr>
             <a:r>
-              <a:rPr lang="en-US" sz="1600" b="1" dirty="0">
+              <a:rPr lang="en-US" sz="1700" b="1" dirty="0">
                 <a:solidFill>
                   <a:srgbClr val="FFFFFF"/>
                 </a:solidFill>
@@ -5402,7 +5402,7 @@
               </a:rPr>
               <a:t>Category 2: Unsupervised Learning</a:t>
             </a:r>
-            <a:endParaRPr lang="en-US" sz="1600" dirty="0"/>
+            <a:endParaRPr lang="en-US" sz="1700" dirty="0"/>
           </a:p>
         </p:txBody>
       </p:sp>
@@ -5561,7 +5561,7 @@
               <a:buNone/>
             </a:pPr>
             <a:r>
-              <a:rPr lang="en-US" sz="1400" b="1" spc="400" kern="0" dirty="0">
+              <a:rPr lang="en-US" sz="1700" b="1" spc="400" kern="0" dirty="0">
                 <a:solidFill>
                   <a:srgbClr val="FFFFFF"/>
                 </a:solidFill>
@@ -5571,7 +5571,7 @@
               </a:rPr>
               <a:t>#2</a:t>
             </a:r>
-            <a:endParaRPr lang="en-US" sz="1400" dirty="0"/>
+            <a:endParaRPr lang="en-US" sz="1700" dirty="0"/>
           </a:p>
         </p:txBody>
       </p:sp>
@@ -5856,7 +5856,7 @@
               <a:buNone/>
             </a:pPr>
             <a:r>
-              <a:rPr lang="en-US" sz="1500" dirty="0">
+              <a:rPr lang="en-US" sz="1700" dirty="0">
                 <a:solidFill>
                   <a:srgbClr val="333D4D"/>
                 </a:solidFill>
@@ -5866,7 +5866,7 @@
               </a:rPr>
               <a:t>A librarian with a crate of unlabelled books. She groups them by 'these feel similar' — romance here, mystery there — without anyone telling her what the genres are.</a:t>
             </a:r>
-            <a:endParaRPr lang="en-US" sz="1500" dirty="0"/>
+            <a:endParaRPr lang="en-US" sz="1700" dirty="0"/>
           </a:p>
         </p:txBody>
       </p:sp>
@@ -5987,7 +5987,7 @@
               <a:buNone/>
             </a:pPr>
             <a:r>
-              <a:rPr lang="en-US" sz="1500" dirty="0">
+              <a:rPr lang="en-US" sz="1700" dirty="0">
                 <a:solidFill>
                   <a:srgbClr val="333D4D"/>
                 </a:solidFill>
@@ -5997,7 +5997,7 @@
               </a:rPr>
               <a:t>•  Customer segmentation</a:t>
             </a:r>
-            <a:endParaRPr lang="en-US" sz="1500" dirty="0"/>
+            <a:endParaRPr lang="en-US" sz="1700" dirty="0"/>
           </a:p>
           <a:p>
             <a:pPr indent="0" marL="0">
@@ -6007,7 +6007,7 @@
               <a:buNone/>
             </a:pPr>
             <a:r>
-              <a:rPr lang="en-US" sz="1500" dirty="0">
+              <a:rPr lang="en-US" sz="1700" dirty="0">
                 <a:solidFill>
                   <a:srgbClr val="333D4D"/>
                 </a:solidFill>
@@ -6017,7 +6017,7 @@
               </a:rPr>
               <a:t>•  Anomaly detection in logs</a:t>
             </a:r>
-            <a:endParaRPr lang="en-US" sz="1500" dirty="0"/>
+            <a:endParaRPr lang="en-US" sz="1700" dirty="0"/>
           </a:p>
           <a:p>
             <a:pPr indent="0" marL="0">
@@ -6027,7 +6027,7 @@
               <a:buNone/>
             </a:pPr>
             <a:r>
-              <a:rPr lang="en-US" sz="1500" dirty="0">
+              <a:rPr lang="en-US" sz="1700" dirty="0">
                 <a:solidFill>
                   <a:srgbClr val="333D4D"/>
                 </a:solidFill>
@@ -6037,7 +6037,7 @@
               </a:rPr>
               <a:t>•  Topic discovery in reviews/tickets</a:t>
             </a:r>
-            <a:endParaRPr lang="en-US" sz="1500" dirty="0"/>
+            <a:endParaRPr lang="en-US" sz="1700" dirty="0"/>
           </a:p>
           <a:p>
             <a:pPr indent="0" marL="0">
@@ -6047,7 +6047,7 @@
               <a:buNone/>
             </a:pPr>
             <a:r>
-              <a:rPr lang="en-US" sz="1500" dirty="0">
+              <a:rPr lang="en-US" sz="1700" dirty="0">
                 <a:solidFill>
                   <a:srgbClr val="333D4D"/>
                 </a:solidFill>
@@ -6057,7 +6057,7 @@
               </a:rPr>
               <a:t>•  Recommendation cohorts</a:t>
             </a:r>
-            <a:endParaRPr lang="en-US" sz="1500" dirty="0"/>
+            <a:endParaRPr lang="en-US" sz="1700" dirty="0"/>
           </a:p>
           <a:p>
             <a:pPr indent="0" marL="0">
@@ -6067,7 +6067,7 @@
               <a:buNone/>
             </a:pPr>
             <a:r>
-              <a:rPr lang="en-US" sz="1500" dirty="0">
+              <a:rPr lang="en-US" sz="1700" dirty="0">
                 <a:solidFill>
                   <a:srgbClr val="333D4D"/>
                 </a:solidFill>
@@ -6077,7 +6077,7 @@
               </a:rPr>
               <a:t>•  Pre-processing for downstream supervised models</a:t>
             </a:r>
-            <a:endParaRPr lang="en-US" sz="1500" dirty="0"/>
+            <a:endParaRPr lang="en-US" sz="1700" dirty="0"/>
           </a:p>
         </p:txBody>
       </p:sp>
@@ -6163,7 +6163,7 @@
               <a:buNone/>
             </a:pPr>
             <a:r>
-              <a:rPr lang="en-US" sz="1600" b="1" dirty="0">
+              <a:rPr lang="en-US" sz="1700" b="1" dirty="0">
                 <a:solidFill>
                   <a:srgbClr val="FFFFFF"/>
                 </a:solidFill>
@@ -6173,7 +6173,7 @@
               </a:rPr>
               <a:t>Category 3: Reinforcement Learning</a:t>
             </a:r>
-            <a:endParaRPr lang="en-US" sz="1600" dirty="0"/>
+            <a:endParaRPr lang="en-US" sz="1700" dirty="0"/>
           </a:p>
         </p:txBody>
       </p:sp>
@@ -6332,7 +6332,7 @@
               <a:buNone/>
             </a:pPr>
             <a:r>
-              <a:rPr lang="en-US" sz="1400" b="1" spc="400" kern="0" dirty="0">
+              <a:rPr lang="en-US" sz="1700" b="1" spc="400" kern="0" dirty="0">
                 <a:solidFill>
                   <a:srgbClr val="FFFFFF"/>
                 </a:solidFill>
@@ -6342,7 +6342,7 @@
               </a:rPr>
               <a:t>#3</a:t>
             </a:r>
-            <a:endParaRPr lang="en-US" sz="1400" dirty="0"/>
+            <a:endParaRPr lang="en-US" sz="1700" dirty="0"/>
           </a:p>
         </p:txBody>
       </p:sp>
@@ -6627,7 +6627,7 @@
               <a:buNone/>
             </a:pPr>
             <a:r>
-              <a:rPr lang="en-US" sz="1500" dirty="0">
+              <a:rPr lang="en-US" sz="1700" dirty="0">
                 <a:solidFill>
                   <a:srgbClr val="333D4D"/>
                 </a:solidFill>
@@ -6637,7 +6637,7 @@
               </a:rPr>
               <a:t>Training a dog with treats. Sit → treat. Bark at the mailman → no treat. Over time the dog learns which actions pay off.</a:t>
             </a:r>
-            <a:endParaRPr lang="en-US" sz="1500" dirty="0"/>
+            <a:endParaRPr lang="en-US" sz="1700" dirty="0"/>
           </a:p>
         </p:txBody>
       </p:sp>
@@ -6758,7 +6758,7 @@
               <a:buNone/>
             </a:pPr>
             <a:r>
-              <a:rPr lang="en-US" sz="1500" dirty="0">
+              <a:rPr lang="en-US" sz="1700" dirty="0">
                 <a:solidFill>
                   <a:srgbClr val="333D4D"/>
                 </a:solidFill>
@@ -6768,7 +6768,7 @@
               </a:rPr>
               <a:t>•  AlphaGo, chess-playing AIs</a:t>
             </a:r>
-            <a:endParaRPr lang="en-US" sz="1500" dirty="0"/>
+            <a:endParaRPr lang="en-US" sz="1700" dirty="0"/>
           </a:p>
           <a:p>
             <a:pPr indent="0" marL="0">
@@ -6778,7 +6778,7 @@
               <a:buNone/>
             </a:pPr>
             <a:r>
-              <a:rPr lang="en-US" sz="1500" dirty="0">
+              <a:rPr lang="en-US" sz="1700" dirty="0">
                 <a:solidFill>
                   <a:srgbClr val="333D4D"/>
                 </a:solidFill>
@@ -6788,7 +6788,7 @@
               </a:rPr>
               <a:t>•  Robot control (warehouse pick-and-pack)</a:t>
             </a:r>
-            <a:endParaRPr lang="en-US" sz="1500" dirty="0"/>
+            <a:endParaRPr lang="en-US" sz="1700" dirty="0"/>
           </a:p>
           <a:p>
             <a:pPr indent="0" marL="0">
@@ -6798,7 +6798,7 @@
               <a:buNone/>
             </a:pPr>
             <a:r>
-              <a:rPr lang="en-US" sz="1500" dirty="0">
+              <a:rPr lang="en-US" sz="1700" dirty="0">
                 <a:solidFill>
                   <a:srgbClr val="333D4D"/>
                 </a:solidFill>
@@ -6808,7 +6808,7 @@
               </a:rPr>
               <a:t>•  Large-scale recommendation engines</a:t>
             </a:r>
-            <a:endParaRPr lang="en-US" sz="1500" dirty="0"/>
+            <a:endParaRPr lang="en-US" sz="1700" dirty="0"/>
           </a:p>
           <a:p>
             <a:pPr indent="0" marL="0">
@@ -6818,7 +6818,7 @@
               <a:buNone/>
             </a:pPr>
             <a:r>
-              <a:rPr lang="en-US" sz="1500" dirty="0">
+              <a:rPr lang="en-US" sz="1700" dirty="0">
                 <a:solidFill>
                   <a:srgbClr val="333D4D"/>
                 </a:solidFill>
@@ -6828,7 +6828,7 @@
               </a:rPr>
               <a:t>•  RLHF in modern LLMs</a:t>
             </a:r>
-            <a:endParaRPr lang="en-US" sz="1500" dirty="0"/>
+            <a:endParaRPr lang="en-US" sz="1700" dirty="0"/>
           </a:p>
           <a:p>
             <a:pPr indent="0" marL="0">
@@ -6838,7 +6838,7 @@
               <a:buNone/>
             </a:pPr>
             <a:r>
-              <a:rPr lang="en-US" sz="1500" dirty="0">
+              <a:rPr lang="en-US" sz="1700" dirty="0">
                 <a:solidFill>
                   <a:srgbClr val="333D4D"/>
                 </a:solidFill>
@@ -6848,7 +6848,7 @@
               </a:rPr>
               <a:t>•  Game-playing agents</a:t>
             </a:r>
-            <a:endParaRPr lang="en-US" sz="1500" dirty="0"/>
+            <a:endParaRPr lang="en-US" sz="1700" dirty="0"/>
           </a:p>
           <a:p>
             <a:pPr indent="0" marL="0">
@@ -6858,7 +6858,7 @@
               <a:buNone/>
             </a:pPr>
             <a:r>
-              <a:rPr lang="en-US" sz="1500" dirty="0">
+              <a:rPr lang="en-US" sz="1700" dirty="0">
                 <a:solidFill>
                   <a:srgbClr val="333D4D"/>
                 </a:solidFill>
@@ -6868,7 +6868,7 @@
               </a:rPr>
               <a:t>•  → Not built in this course (recognise, don't implement).</a:t>
             </a:r>
-            <a:endParaRPr lang="en-US" sz="1500" dirty="0"/>
+            <a:endParaRPr lang="en-US" sz="1700" dirty="0"/>
           </a:p>
         </p:txBody>
       </p:sp>
@@ -7205,7 +7205,7 @@
               <a:buNone/>
             </a:pPr>
             <a:r>
-              <a:rPr lang="en-US" sz="1600" b="1" dirty="0">
+              <a:rPr lang="en-US" sz="1700" b="1" dirty="0">
                 <a:solidFill>
                   <a:srgbClr val="FFFFFF"/>
                 </a:solidFill>
@@ -7215,7 +7215,7 @@
               </a:rPr>
               <a:t>→</a:t>
             </a:r>
-            <a:endParaRPr lang="en-US" sz="1600" dirty="0"/>
+            <a:endParaRPr lang="en-US" sz="1700" dirty="0"/>
           </a:p>
         </p:txBody>
       </p:sp>
@@ -7310,7 +7310,7 @@
               <a:buNone/>
             </a:pPr>
             <a:r>
-              <a:rPr lang="en-US" sz="1600" b="1" dirty="0">
+              <a:rPr lang="en-US" sz="1700" b="1" dirty="0">
                 <a:solidFill>
                   <a:srgbClr val="FFFFFF"/>
                 </a:solidFill>
@@ -7320,7 +7320,7 @@
               </a:rPr>
               <a:t>→</a:t>
             </a:r>
-            <a:endParaRPr lang="en-US" sz="1600" dirty="0"/>
+            <a:endParaRPr lang="en-US" sz="1700" dirty="0"/>
           </a:p>
         </p:txBody>
       </p:sp>
@@ -7415,7 +7415,7 @@
               <a:buNone/>
             </a:pPr>
             <a:r>
-              <a:rPr lang="en-US" sz="1600" b="1" dirty="0">
+              <a:rPr lang="en-US" sz="1700" b="1" dirty="0">
                 <a:solidFill>
                   <a:srgbClr val="FFFFFF"/>
                 </a:solidFill>
@@ -7425,7 +7425,7 @@
               </a:rPr>
               <a:t>→</a:t>
             </a:r>
-            <a:endParaRPr lang="en-US" sz="1600" dirty="0"/>
+            <a:endParaRPr lang="en-US" sz="1700" dirty="0"/>
           </a:p>
         </p:txBody>
       </p:sp>
@@ -7573,7 +7573,7 @@
               <a:buNone/>
             </a:pPr>
             <a:r>
-              <a:rPr lang="en-US" sz="1400" dirty="0">
+              <a:rPr lang="en-US" sz="1700" dirty="0">
                 <a:solidFill>
                   <a:srgbClr val="FFFFFF">
                     <a:alpha val="70000"/>
@@ -7671,7 +7671,7 @@
               <a:buNone/>
             </a:pPr>
             <a:r>
-              <a:rPr lang="en-US" sz="1600" b="1" dirty="0">
+              <a:rPr lang="en-US" sz="1700" b="1" dirty="0">
                 <a:solidFill>
                   <a:srgbClr val="FFFFFF"/>
                 </a:solidFill>
@@ -7681,7 +7681,7 @@
               </a:rPr>
               <a:t>The 7-Step ML Workflow</a:t>
             </a:r>
-            <a:endParaRPr lang="en-US" sz="1600" dirty="0"/>
+            <a:endParaRPr lang="en-US" sz="1700" dirty="0"/>
           </a:p>
         </p:txBody>
       </p:sp>
@@ -9189,7 +9189,7 @@
               <a:buNone/>
             </a:pPr>
             <a:r>
-              <a:rPr lang="en-US" sz="1600" b="1" dirty="0">
+              <a:rPr lang="en-US" sz="1700" b="1" dirty="0">
                 <a:solidFill>
                   <a:srgbClr val="FFFFFF"/>
                 </a:solidFill>
@@ -9199,7 +9199,7 @@
               </a:rPr>
               <a:t>Where the Time Actually Goes</a:t>
             </a:r>
-            <a:endParaRPr lang="en-US" sz="1600" dirty="0"/>
+            <a:endParaRPr lang="en-US" sz="1700" dirty="0"/>
           </a:p>
         </p:txBody>
       </p:sp>
@@ -9372,7 +9372,7 @@
               <a:buNone/>
             </a:pPr>
             <a:r>
-              <a:rPr lang="en-US" sz="1500" b="1" spc="300" kern="0" dirty="0">
+              <a:rPr lang="en-US" sz="1700" b="1" spc="300" kern="0" dirty="0">
                 <a:solidFill>
                   <a:srgbClr val="5F6B7A"/>
                 </a:solidFill>
@@ -9382,7 +9382,7 @@
               </a:rPr>
               <a:t>Steps 1-3</a:t>
             </a:r>
-            <a:endParaRPr lang="en-US" sz="1500" dirty="0"/>
+            <a:endParaRPr lang="en-US" sz="1700" dirty="0"/>
           </a:p>
         </p:txBody>
       </p:sp>
@@ -9539,7 +9539,7 @@
               <a:buNone/>
             </a:pPr>
             <a:r>
-              <a:rPr lang="en-US" sz="1500" b="1" spc="300" kern="0" dirty="0">
+              <a:rPr lang="en-US" sz="1700" b="1" spc="300" kern="0" dirty="0">
                 <a:solidFill>
                   <a:srgbClr val="5F6B7A"/>
                 </a:solidFill>
@@ -9549,7 +9549,7 @@
               </a:rPr>
               <a:t>Steps 4-5</a:t>
             </a:r>
-            <a:endParaRPr lang="en-US" sz="1500" dirty="0"/>
+            <a:endParaRPr lang="en-US" sz="1700" dirty="0"/>
           </a:p>
         </p:txBody>
       </p:sp>
@@ -9706,7 +9706,7 @@
               <a:buNone/>
             </a:pPr>
             <a:r>
-              <a:rPr lang="en-US" sz="1500" b="1" spc="300" kern="0" dirty="0">
+              <a:rPr lang="en-US" sz="1700" b="1" spc="300" kern="0" dirty="0">
                 <a:solidFill>
                   <a:srgbClr val="5F6B7A"/>
                 </a:solidFill>
@@ -9716,7 +9716,7 @@
               </a:rPr>
               <a:t>Steps 6-7</a:t>
             </a:r>
-            <a:endParaRPr lang="en-US" sz="1500" dirty="0"/>
+            <a:endParaRPr lang="en-US" sz="1700" dirty="0"/>
           </a:p>
         </p:txBody>
       </p:sp>
@@ -10047,7 +10047,7 @@
               <a:buNone/>
             </a:pPr>
             <a:r>
-              <a:rPr lang="en-US" sz="1600" b="1" dirty="0">
+              <a:rPr lang="en-US" sz="1700" b="1" dirty="0">
                 <a:solidFill>
                   <a:srgbClr val="FFFFFF"/>
                 </a:solidFill>
@@ -10057,7 +10057,7 @@
               </a:rPr>
               <a:t>The 7 Steps — Cheatsheet</a:t>
             </a:r>
-            <a:endParaRPr lang="en-US" sz="1600" dirty="0"/>
+            <a:endParaRPr lang="en-US" sz="1700" dirty="0"/>
           </a:p>
         </p:txBody>
       </p:sp>
@@ -10242,7 +10242,7 @@
                         <a:buNone/>
                       </a:pPr>
                       <a:r>
-                        <a:rPr lang="en-US" sz="1400" b="1" spc="400" kern="0" dirty="0">
+                        <a:rPr lang="en-US" sz="1700" b="1" spc="400" kern="0" dirty="0">
                           <a:solidFill>
                             <a:srgbClr val="FFFFFF"/>
                           </a:solidFill>
@@ -10252,7 +10252,7 @@
                         </a:rPr>
                         <a:t>STEP</a:t>
                       </a:r>
-                      <a:endParaRPr lang="en-US" sz="1400" dirty="0">
+                      <a:endParaRPr lang="en-US" sz="1700" dirty="0">
                         <a:latin typeface="Open Sans" charset="0"/>
                         <a:ea typeface="Open Sans" charset="0"/>
                         <a:cs typeface="Open Sans" charset="0"/>
@@ -10310,7 +10310,7 @@
                         <a:buNone/>
                       </a:pPr>
                       <a:r>
-                        <a:rPr lang="en-US" sz="1400" b="1" spc="400" kern="0" dirty="0">
+                        <a:rPr lang="en-US" sz="1700" b="1" spc="400" kern="0" dirty="0">
                           <a:solidFill>
                             <a:srgbClr val="FFFFFF"/>
                           </a:solidFill>
@@ -10320,7 +10320,7 @@
                         </a:rPr>
                         <a:t>WHAT HAPPENS</a:t>
                       </a:r>
-                      <a:endParaRPr lang="en-US" sz="1400" dirty="0">
+                      <a:endParaRPr lang="en-US" sz="1700" dirty="0">
                         <a:latin typeface="Open Sans" charset="0"/>
                         <a:ea typeface="Open Sans" charset="0"/>
                         <a:cs typeface="Open Sans" charset="0"/>
@@ -10378,7 +10378,7 @@
                         <a:buNone/>
                       </a:pPr>
                       <a:r>
-                        <a:rPr lang="en-US" sz="1400" b="1" spc="400" kern="0" dirty="0">
+                        <a:rPr lang="en-US" sz="1700" b="1" spc="400" kern="0" dirty="0">
                           <a:solidFill>
                             <a:srgbClr val="FFFFFF"/>
                           </a:solidFill>
@@ -10388,7 +10388,7 @@
                         </a:rPr>
                         <a:t>WHERE BEGINNERS GET STUCK</a:t>
                       </a:r>
-                      <a:endParaRPr lang="en-US" sz="1400" dirty="0">
+                      <a:endParaRPr lang="en-US" sz="1700" dirty="0">
                         <a:latin typeface="Open Sans" charset="0"/>
                         <a:ea typeface="Open Sans" charset="0"/>
                         <a:cs typeface="Open Sans" charset="0"/>
@@ -10448,7 +10448,7 @@
                         <a:buNone/>
                       </a:pPr>
                       <a:r>
-                        <a:rPr lang="en-US" sz="1400" b="1" dirty="0">
+                        <a:rPr lang="en-US" sz="1700" b="1" dirty="0">
                           <a:solidFill>
                             <a:srgbClr val="C8102E"/>
                           </a:solidFill>
@@ -10458,7 +10458,7 @@
                         </a:rPr>
                         <a:t>1. Frame</a:t>
                       </a:r>
-                      <a:endParaRPr lang="en-US" sz="1400" dirty="0">
+                      <a:endParaRPr lang="en-US" sz="1700" dirty="0">
                         <a:latin typeface="Open Sans" charset="0"/>
                         <a:ea typeface="Open Sans" charset="0"/>
                         <a:cs typeface="Open Sans" charset="0"/>
@@ -10513,7 +10513,7 @@
                         <a:buNone/>
                       </a:pPr>
                       <a:r>
-                        <a:rPr lang="en-US" sz="1400" dirty="0">
+                        <a:rPr lang="en-US" sz="1700" dirty="0">
                           <a:solidFill>
                             <a:srgbClr val="333D4D"/>
                           </a:solidFill>
@@ -10523,7 +10523,7 @@
                         </a:rPr>
                         <a:t>Business question, success metric, cost of wrongness</a:t>
                       </a:r>
-                      <a:endParaRPr lang="en-US" sz="1400" dirty="0">
+                      <a:endParaRPr lang="en-US" sz="1700" dirty="0">
                         <a:latin typeface="Open Sans" charset="0"/>
                         <a:ea typeface="Open Sans" charset="0"/>
                         <a:cs typeface="Open Sans" charset="0"/>
@@ -10578,7 +10578,7 @@
                         <a:buNone/>
                       </a:pPr>
                       <a:r>
-                        <a:rPr lang="en-US" sz="1400" i="1" dirty="0">
+                        <a:rPr lang="en-US" sz="1700" i="1" dirty="0">
                           <a:solidFill>
                             <a:srgbClr val="C8102E"/>
                           </a:solidFill>
@@ -10588,7 +10588,7 @@
                         </a:rPr>
                         <a:t>Skipping it entirely</a:t>
                       </a:r>
-                      <a:endParaRPr lang="en-US" sz="1400" dirty="0">
+                      <a:endParaRPr lang="en-US" sz="1700" dirty="0">
                         <a:latin typeface="Open Sans" charset="0"/>
                         <a:ea typeface="Open Sans" charset="0"/>
                         <a:cs typeface="Open Sans" charset="0"/>
@@ -10645,7 +10645,7 @@
                         <a:buNone/>
                       </a:pPr>
                       <a:r>
-                        <a:rPr lang="en-US" sz="1400" b="1" dirty="0">
+                        <a:rPr lang="en-US" sz="1700" b="1" dirty="0">
                           <a:solidFill>
                             <a:srgbClr val="C8102E"/>
                           </a:solidFill>
@@ -10655,7 +10655,7 @@
                         </a:rPr>
                         <a:t>2. Collect</a:t>
                       </a:r>
-                      <a:endParaRPr lang="en-US" sz="1400" dirty="0">
+                      <a:endParaRPr lang="en-US" sz="1700" dirty="0">
                         <a:latin typeface="Open Sans" charset="0"/>
                         <a:ea typeface="Open Sans" charset="0"/>
                         <a:cs typeface="Open Sans" charset="0"/>
@@ -10710,7 +10710,7 @@
                         <a:buNone/>
                       </a:pPr>
                       <a:r>
-                        <a:rPr lang="en-US" sz="1400" dirty="0">
+                        <a:rPr lang="en-US" sz="1700" dirty="0">
                           <a:solidFill>
                             <a:srgbClr val="333D4D"/>
                           </a:solidFill>
@@ -10720,7 +10720,7 @@
                         </a:rPr>
                         <a:t>Gather features (and labels, if training)</a:t>
                       </a:r>
-                      <a:endParaRPr lang="en-US" sz="1400" dirty="0">
+                      <a:endParaRPr lang="en-US" sz="1700" dirty="0">
                         <a:latin typeface="Open Sans" charset="0"/>
                         <a:ea typeface="Open Sans" charset="0"/>
                         <a:cs typeface="Open Sans" charset="0"/>
@@ -10775,7 +10775,7 @@
                         <a:buNone/>
                       </a:pPr>
                       <a:r>
-                        <a:rPr lang="en-US" sz="1400" i="1" dirty="0">
+                        <a:rPr lang="en-US" sz="1700" i="1" dirty="0">
                           <a:solidFill>
                             <a:srgbClr val="C8102E"/>
                           </a:solidFill>
@@ -10785,7 +10785,7 @@
                         </a:rPr>
                         <a:t>Assuming data exists when it doesn't</a:t>
                       </a:r>
-                      <a:endParaRPr lang="en-US" sz="1400" dirty="0">
+                      <a:endParaRPr lang="en-US" sz="1700" dirty="0">
                         <a:latin typeface="Open Sans" charset="0"/>
                         <a:ea typeface="Open Sans" charset="0"/>
                         <a:cs typeface="Open Sans" charset="0"/>
@@ -10842,7 +10842,7 @@
                         <a:buNone/>
                       </a:pPr>
                       <a:r>
-                        <a:rPr lang="en-US" sz="1400" b="1" dirty="0">
+                        <a:rPr lang="en-US" sz="1700" b="1" dirty="0">
                           <a:solidFill>
                             <a:srgbClr val="C8102E"/>
                           </a:solidFill>
@@ -10852,7 +10852,7 @@
                         </a:rPr>
                         <a:t>3. Clean</a:t>
                       </a:r>
-                      <a:endParaRPr lang="en-US" sz="1400" dirty="0">
+                      <a:endParaRPr lang="en-US" sz="1700" dirty="0">
                         <a:latin typeface="Open Sans" charset="0"/>
                         <a:ea typeface="Open Sans" charset="0"/>
                         <a:cs typeface="Open Sans" charset="0"/>
@@ -10907,7 +10907,7 @@
                         <a:buNone/>
                       </a:pPr>
                       <a:r>
-                        <a:rPr lang="en-US" sz="1400" dirty="0">
+                        <a:rPr lang="en-US" sz="1700" dirty="0">
                           <a:solidFill>
                             <a:srgbClr val="333D4D"/>
                           </a:solidFill>
@@ -10917,7 +10917,7 @@
                         </a:rPr>
                         <a:t>Fix missing, remove duplicates, check for bias</a:t>
                       </a:r>
-                      <a:endParaRPr lang="en-US" sz="1400" dirty="0">
+                      <a:endParaRPr lang="en-US" sz="1700" dirty="0">
                         <a:latin typeface="Open Sans" charset="0"/>
                         <a:ea typeface="Open Sans" charset="0"/>
                         <a:cs typeface="Open Sans" charset="0"/>
@@ -10972,7 +10972,7 @@
                         <a:buNone/>
                       </a:pPr>
                       <a:r>
-                        <a:rPr lang="en-US" sz="1400" i="1" dirty="0">
+                        <a:rPr lang="en-US" sz="1700" i="1" dirty="0">
                           <a:solidFill>
                             <a:srgbClr val="C8102E"/>
                           </a:solidFill>
@@ -10982,7 +10982,7 @@
                         </a:rPr>
                         <a:t>Underestimating how long this takes</a:t>
                       </a:r>
-                      <a:endParaRPr lang="en-US" sz="1400" dirty="0">
+                      <a:endParaRPr lang="en-US" sz="1700" dirty="0">
                         <a:latin typeface="Open Sans" charset="0"/>
                         <a:ea typeface="Open Sans" charset="0"/>
                         <a:cs typeface="Open Sans" charset="0"/>
@@ -11039,7 +11039,7 @@
                         <a:buNone/>
                       </a:pPr>
                       <a:r>
-                        <a:rPr lang="en-US" sz="1400" b="1" dirty="0">
+                        <a:rPr lang="en-US" sz="1700" b="1" dirty="0">
                           <a:solidFill>
                             <a:srgbClr val="1B2A4A"/>
                           </a:solidFill>
@@ -11049,7 +11049,7 @@
                         </a:rPr>
                         <a:t>4. Train</a:t>
                       </a:r>
-                      <a:endParaRPr lang="en-US" sz="1400" dirty="0">
+                      <a:endParaRPr lang="en-US" sz="1700" dirty="0">
                         <a:latin typeface="Open Sans" charset="0"/>
                         <a:ea typeface="Open Sans" charset="0"/>
                         <a:cs typeface="Open Sans" charset="0"/>
@@ -11104,7 +11104,7 @@
                         <a:buNone/>
                       </a:pPr>
                       <a:r>
-                        <a:rPr lang="en-US" sz="1400" dirty="0">
+                        <a:rPr lang="en-US" sz="1700" dirty="0">
                           <a:solidFill>
                             <a:srgbClr val="333D4D"/>
                           </a:solidFill>
@@ -11114,7 +11114,7 @@
                         </a:rPr>
                         <a:t>Fit a model — or reuse a pre-trained one</a:t>
                       </a:r>
-                      <a:endParaRPr lang="en-US" sz="1400" dirty="0">
+                      <a:endParaRPr lang="en-US" sz="1700" dirty="0">
                         <a:latin typeface="Open Sans" charset="0"/>
                         <a:ea typeface="Open Sans" charset="0"/>
                         <a:cs typeface="Open Sans" charset="0"/>
@@ -11169,7 +11169,7 @@
                         <a:buNone/>
                       </a:pPr>
                       <a:r>
-                        <a:rPr lang="en-US" sz="1400" i="1" dirty="0">
+                        <a:rPr lang="en-US" sz="1700" i="1" dirty="0">
                           <a:solidFill>
                             <a:srgbClr val="C8102E"/>
                           </a:solidFill>
@@ -11179,7 +11179,7 @@
                         </a:rPr>
                         <a:t>Training from scratch when one exists</a:t>
                       </a:r>
-                      <a:endParaRPr lang="en-US" sz="1400" dirty="0">
+                      <a:endParaRPr lang="en-US" sz="1700" dirty="0">
                         <a:latin typeface="Open Sans" charset="0"/>
                         <a:ea typeface="Open Sans" charset="0"/>
                         <a:cs typeface="Open Sans" charset="0"/>
@@ -11236,7 +11236,7 @@
                         <a:buNone/>
                       </a:pPr>
                       <a:r>
-                        <a:rPr lang="en-US" sz="1400" b="1" dirty="0">
+                        <a:rPr lang="en-US" sz="1700" b="1" dirty="0">
                           <a:solidFill>
                             <a:srgbClr val="1B2A4A"/>
                           </a:solidFill>
@@ -11246,7 +11246,7 @@
                         </a:rPr>
                         <a:t>5. Evaluate</a:t>
                       </a:r>
-                      <a:endParaRPr lang="en-US" sz="1400" dirty="0">
+                      <a:endParaRPr lang="en-US" sz="1700" dirty="0">
                         <a:latin typeface="Open Sans" charset="0"/>
                         <a:ea typeface="Open Sans" charset="0"/>
                         <a:cs typeface="Open Sans" charset="0"/>
@@ -11301,7 +11301,7 @@
                         <a:buNone/>
                       </a:pPr>
                       <a:r>
-                        <a:rPr lang="en-US" sz="1400" dirty="0">
+                        <a:rPr lang="en-US" sz="1700" dirty="0">
                           <a:solidFill>
                             <a:srgbClr val="333D4D"/>
                           </a:solidFill>
@@ -11311,7 +11311,7 @@
                         </a:rPr>
                         <a:t>Hold-out test · check WHERE it's wrong</a:t>
                       </a:r>
-                      <a:endParaRPr lang="en-US" sz="1400" dirty="0">
+                      <a:endParaRPr lang="en-US" sz="1700" dirty="0">
                         <a:latin typeface="Open Sans" charset="0"/>
                         <a:ea typeface="Open Sans" charset="0"/>
                         <a:cs typeface="Open Sans" charset="0"/>
@@ -11366,7 +11366,7 @@
                         <a:buNone/>
                       </a:pPr>
                       <a:r>
-                        <a:rPr lang="en-US" sz="1400" i="1" dirty="0">
+                        <a:rPr lang="en-US" sz="1700" i="1" dirty="0">
                           <a:solidFill>
                             <a:srgbClr val="C8102E"/>
                           </a:solidFill>
@@ -11376,7 +11376,7 @@
                         </a:rPr>
                         <a:t>Reporting one accuracy number</a:t>
                       </a:r>
-                      <a:endParaRPr lang="en-US" sz="1400" dirty="0">
+                      <a:endParaRPr lang="en-US" sz="1700" dirty="0">
                         <a:latin typeface="Open Sans" charset="0"/>
                         <a:ea typeface="Open Sans" charset="0"/>
                         <a:cs typeface="Open Sans" charset="0"/>
@@ -11433,7 +11433,7 @@
                         <a:buNone/>
                       </a:pPr>
                       <a:r>
-                        <a:rPr lang="en-US" sz="1400" b="1" dirty="0">
+                        <a:rPr lang="en-US" sz="1700" b="1" dirty="0">
                           <a:solidFill>
                             <a:srgbClr val="2C5697"/>
                           </a:solidFill>
@@ -11443,7 +11443,7 @@
                         </a:rPr>
                         <a:t>6. Deploy</a:t>
                       </a:r>
-                      <a:endParaRPr lang="en-US" sz="1400" dirty="0">
+                      <a:endParaRPr lang="en-US" sz="1700" dirty="0">
                         <a:latin typeface="Open Sans" charset="0"/>
                         <a:ea typeface="Open Sans" charset="0"/>
                         <a:cs typeface="Open Sans" charset="0"/>
@@ -11498,7 +11498,7 @@
                         <a:buNone/>
                       </a:pPr>
                       <a:r>
-                        <a:rPr lang="en-US" sz="1400" dirty="0">
+                        <a:rPr lang="en-US" sz="1700" dirty="0">
                           <a:solidFill>
                             <a:srgbClr val="333D4D"/>
                           </a:solidFill>
@@ -11508,7 +11508,7 @@
                         </a:rPr>
                         <a:t>Pipeline · dashboard · API</a:t>
                       </a:r>
-                      <a:endParaRPr lang="en-US" sz="1400" dirty="0">
+                      <a:endParaRPr lang="en-US" sz="1700" dirty="0">
                         <a:latin typeface="Open Sans" charset="0"/>
                         <a:ea typeface="Open Sans" charset="0"/>
                         <a:cs typeface="Open Sans" charset="0"/>
@@ -11563,7 +11563,7 @@
                         <a:buNone/>
                       </a:pPr>
                       <a:r>
-                        <a:rPr lang="en-US" sz="1400" i="1" dirty="0">
+                        <a:rPr lang="en-US" sz="1700" i="1" dirty="0">
                           <a:solidFill>
                             <a:srgbClr val="C8102E"/>
                           </a:solidFill>
@@ -11573,7 +11573,7 @@
                         </a:rPr>
                         <a:t>Leaving the model stuck in a notebook</a:t>
                       </a:r>
-                      <a:endParaRPr lang="en-US" sz="1400" dirty="0">
+                      <a:endParaRPr lang="en-US" sz="1700" dirty="0">
                         <a:latin typeface="Open Sans" charset="0"/>
                         <a:ea typeface="Open Sans" charset="0"/>
                         <a:cs typeface="Open Sans" charset="0"/>
@@ -11630,7 +11630,7 @@
                         <a:buNone/>
                       </a:pPr>
                       <a:r>
-                        <a:rPr lang="en-US" sz="1400" b="1" dirty="0">
+                        <a:rPr lang="en-US" sz="1700" b="1" dirty="0">
                           <a:solidFill>
                             <a:srgbClr val="2C5697"/>
                           </a:solidFill>
@@ -11640,7 +11640,7 @@
                         </a:rPr>
                         <a:t>7. Monitor</a:t>
                       </a:r>
-                      <a:endParaRPr lang="en-US" sz="1400" dirty="0">
+                      <a:endParaRPr lang="en-US" sz="1700" dirty="0">
                         <a:latin typeface="Open Sans" charset="0"/>
                         <a:ea typeface="Open Sans" charset="0"/>
                         <a:cs typeface="Open Sans" charset="0"/>
@@ -11695,7 +11695,7 @@
                         <a:buNone/>
                       </a:pPr>
                       <a:r>
-                        <a:rPr lang="en-US" sz="1400" dirty="0">
+                        <a:rPr lang="en-US" sz="1700" dirty="0">
                           <a:solidFill>
                             <a:srgbClr val="333D4D"/>
                           </a:solidFill>
@@ -11705,7 +11705,7 @@
                         </a:rPr>
                         <a:t>Track performance over time</a:t>
                       </a:r>
-                      <a:endParaRPr lang="en-US" sz="1400" dirty="0">
+                      <a:endParaRPr lang="en-US" sz="1700" dirty="0">
                         <a:latin typeface="Open Sans" charset="0"/>
                         <a:ea typeface="Open Sans" charset="0"/>
                         <a:cs typeface="Open Sans" charset="0"/>
@@ -11760,7 +11760,7 @@
                         <a:buNone/>
                       </a:pPr>
                       <a:r>
-                        <a:rPr lang="en-US" sz="1400" i="1" dirty="0">
+                        <a:rPr lang="en-US" sz="1700" i="1" dirty="0">
                           <a:solidFill>
                             <a:srgbClr val="C8102E"/>
                           </a:solidFill>
@@ -11770,7 +11770,7 @@
                         </a:rPr>
                         <a:t>Assuming ‘trained once = good forever’</a:t>
                       </a:r>
-                      <a:endParaRPr lang="en-US" sz="1400" dirty="0">
+                      <a:endParaRPr lang="en-US" sz="1700" dirty="0">
                         <a:latin typeface="Open Sans" charset="0"/>
                         <a:ea typeface="Open Sans" charset="0"/>
                         <a:cs typeface="Open Sans" charset="0"/>
@@ -11903,7 +11903,7 @@
               <a:buNone/>
             </a:pPr>
             <a:r>
-              <a:rPr lang="en-US" sz="1600" b="1" dirty="0">
+              <a:rPr lang="en-US" sz="1700" b="1" dirty="0">
                 <a:solidFill>
                   <a:srgbClr val="FFFFFF"/>
                 </a:solidFill>
@@ -11913,7 +11913,7 @@
               </a:rPr>
               <a:t>Step 1 Is Where Projects Live or Die</a:t>
             </a:r>
-            <a:endParaRPr lang="en-US" sz="1600" dirty="0"/>
+            <a:endParaRPr lang="en-US" sz="1700" dirty="0"/>
           </a:p>
         </p:txBody>
       </p:sp>
@@ -12115,7 +12115,7 @@
               <a:buNone/>
             </a:pPr>
             <a:r>
-              <a:rPr lang="en-US" sz="1400" b="1" spc="300" kern="0" dirty="0">
+              <a:rPr lang="en-US" sz="1700" b="1" spc="300" kern="0" dirty="0">
                 <a:solidFill>
                   <a:srgbClr val="5F6B7A"/>
                 </a:solidFill>
@@ -12125,7 +12125,7 @@
               </a:rPr>
               <a:t>The four questions every project must answer BEFORE touching data:</a:t>
             </a:r>
-            <a:endParaRPr lang="en-US" sz="1400" dirty="0"/>
+            <a:endParaRPr lang="en-US" sz="1700" dirty="0"/>
           </a:p>
         </p:txBody>
       </p:sp>
@@ -12979,7 +12979,7 @@
               <a:buNone/>
             </a:pPr>
             <a:r>
-              <a:rPr lang="en-US" sz="1600" b="1" dirty="0">
+              <a:rPr lang="en-US" sz="1700" b="1" dirty="0">
                 <a:solidFill>
                   <a:srgbClr val="FFFFFF"/>
                 </a:solidFill>
@@ -12989,7 +12989,7 @@
               </a:rPr>
               <a:t>Where Does Machine Learning Fit?</a:t>
             </a:r>
-            <a:endParaRPr lang="en-US" sz="1600" dirty="0"/>
+            <a:endParaRPr lang="en-US" sz="1700" dirty="0"/>
           </a:p>
         </p:txBody>
       </p:sp>
@@ -13290,7 +13290,7 @@
               <a:buNone/>
             </a:pPr>
             <a:r>
-              <a:rPr lang="en-US" sz="1500" dirty="0">
+              <a:rPr lang="en-US" sz="1700" dirty="0">
                 <a:solidFill>
                   <a:srgbClr val="333D4D"/>
                 </a:solidFill>
@@ -13300,7 +13300,7 @@
               </a:rPr>
               <a:t>Describe what happened.</a:t>
             </a:r>
-            <a:endParaRPr lang="en-US" sz="1500" dirty="0"/>
+            <a:endParaRPr lang="en-US" sz="1700" dirty="0"/>
           </a:p>
         </p:txBody>
       </p:sp>
@@ -13418,7 +13418,7 @@
               <a:buNone/>
             </a:pPr>
             <a:r>
-              <a:rPr lang="en-US" sz="1400" i="1" dirty="0">
+              <a:rPr lang="en-US" sz="1700" i="1" dirty="0">
                 <a:solidFill>
                   <a:srgbClr val="333D4D"/>
                 </a:solidFill>
@@ -13428,7 +13428,7 @@
               </a:rPr>
               <a:t>“Reviews dropped 12% last month.”</a:t>
             </a:r>
-            <a:endParaRPr lang="en-US" sz="1400" dirty="0"/>
+            <a:endParaRPr lang="en-US" sz="1700" dirty="0"/>
           </a:p>
         </p:txBody>
       </p:sp>
@@ -13585,7 +13585,7 @@
               <a:buNone/>
             </a:pPr>
             <a:r>
-              <a:rPr lang="en-US" sz="1500" dirty="0">
+              <a:rPr lang="en-US" sz="1700" dirty="0">
                 <a:solidFill>
                   <a:srgbClr val="333D4D"/>
                 </a:solidFill>
@@ -13595,7 +13595,7 @@
               </a:rPr>
               <a:t>Build the pipes between systems.</a:t>
             </a:r>
-            <a:endParaRPr lang="en-US" sz="1500" dirty="0"/>
+            <a:endParaRPr lang="en-US" sz="1700" dirty="0"/>
           </a:p>
         </p:txBody>
       </p:sp>
@@ -13713,7 +13713,7 @@
               <a:buNone/>
             </a:pPr>
             <a:r>
-              <a:rPr lang="en-US" sz="1400" i="1" dirty="0">
+              <a:rPr lang="en-US" sz="1700" i="1" dirty="0">
                 <a:solidFill>
                   <a:srgbClr val="333D4D"/>
                 </a:solidFill>
@@ -13723,7 +13723,7 @@
               </a:rPr>
               <a:t>“Reviews land in the warehouse every night.”</a:t>
             </a:r>
-            <a:endParaRPr lang="en-US" sz="1400" dirty="0"/>
+            <a:endParaRPr lang="en-US" sz="1700" dirty="0"/>
           </a:p>
         </p:txBody>
       </p:sp>
@@ -13944,7 +13944,7 @@
               <a:buNone/>
             </a:pPr>
             <a:r>
-              <a:rPr lang="en-US" sz="1500" dirty="0">
+              <a:rPr lang="en-US" sz="1700" dirty="0">
                 <a:solidFill>
                   <a:srgbClr val="333D4D"/>
                 </a:solidFill>
@@ -13954,7 +13954,7 @@
               </a:rPr>
               <a:t>Label or forecast things no human has seen yet.</a:t>
             </a:r>
-            <a:endParaRPr lang="en-US" sz="1500" dirty="0"/>
+            <a:endParaRPr lang="en-US" sz="1700" dirty="0"/>
           </a:p>
         </p:txBody>
       </p:sp>
@@ -14072,7 +14072,7 @@
               <a:buNone/>
             </a:pPr>
             <a:r>
-              <a:rPr lang="en-US" sz="1400" i="1" dirty="0">
+              <a:rPr lang="en-US" sz="1700" i="1" dirty="0">
                 <a:solidFill>
                   <a:srgbClr val="333D4D"/>
                 </a:solidFill>
@@ -14082,7 +14082,7 @@
               </a:rPr>
               <a:t>“Label 10,000 reviews — positive or negative.”</a:t>
             </a:r>
-            <a:endParaRPr lang="en-US" sz="1400" dirty="0"/>
+            <a:endParaRPr lang="en-US" sz="1700" dirty="0"/>
           </a:p>
         </p:txBody>
       </p:sp>
@@ -14419,7 +14419,7 @@
               <a:buNone/>
             </a:pPr>
             <a:r>
-              <a:rPr lang="en-US" sz="1400" b="1" dirty="0">
+              <a:rPr lang="en-US" sz="1700" b="1" dirty="0">
                 <a:solidFill>
                   <a:srgbClr val="FFFFFF"/>
                 </a:solidFill>
@@ -14429,7 +14429,7 @@
               </a:rPr>
               <a:t>1</a:t>
             </a:r>
-            <a:endParaRPr lang="en-US" sz="1400" dirty="0"/>
+            <a:endParaRPr lang="en-US" sz="1700" dirty="0"/>
           </a:p>
         </p:txBody>
       </p:sp>
@@ -14524,7 +14524,7 @@
               <a:buNone/>
             </a:pPr>
             <a:r>
-              <a:rPr lang="en-US" sz="1400" b="1" dirty="0">
+              <a:rPr lang="en-US" sz="1700" b="1" dirty="0">
                 <a:solidFill>
                   <a:srgbClr val="FFFFFF"/>
                 </a:solidFill>
@@ -14534,7 +14534,7 @@
               </a:rPr>
               <a:t>2</a:t>
             </a:r>
-            <a:endParaRPr lang="en-US" sz="1400" dirty="0"/>
+            <a:endParaRPr lang="en-US" sz="1700" dirty="0"/>
           </a:p>
         </p:txBody>
       </p:sp>
@@ -14629,7 +14629,7 @@
               <a:buNone/>
             </a:pPr>
             <a:r>
-              <a:rPr lang="en-US" sz="1400" b="1" dirty="0">
+              <a:rPr lang="en-US" sz="1700" b="1" dirty="0">
                 <a:solidFill>
                   <a:srgbClr val="FFFFFF"/>
                 </a:solidFill>
@@ -14639,7 +14639,7 @@
               </a:rPr>
               <a:t>3</a:t>
             </a:r>
-            <a:endParaRPr lang="en-US" sz="1400" dirty="0"/>
+            <a:endParaRPr lang="en-US" sz="1700" dirty="0"/>
           </a:p>
         </p:txBody>
       </p:sp>
@@ -14787,7 +14787,7 @@
               <a:buNone/>
             </a:pPr>
             <a:r>
-              <a:rPr lang="en-US" sz="1400" dirty="0">
+              <a:rPr lang="en-US" sz="1700" dirty="0">
                 <a:solidFill>
                   <a:srgbClr val="FFFFFF">
                     <a:alpha val="70000"/>
@@ -14965,7 +14965,7 @@
               <a:buNone/>
             </a:pPr>
             <a:r>
-              <a:rPr lang="en-US" sz="1600" i="1" dirty="0">
+              <a:rPr lang="en-US" sz="1700" i="1" dirty="0">
                 <a:solidFill>
                   <a:srgbClr val="FFFFFF">
                     <a:alpha val="75000"/>
@@ -14977,7 +14977,7 @@
               </a:rPr>
               <a:t>Priya, after seeing Sarah's numbers…</a:t>
             </a:r>
-            <a:endParaRPr lang="en-US" sz="1600" dirty="0"/>
+            <a:endParaRPr lang="en-US" sz="1700" dirty="0"/>
           </a:p>
         </p:txBody>
       </p:sp>
@@ -15245,7 +15245,7 @@
               <a:buNone/>
             </a:pPr>
             <a:r>
-              <a:rPr lang="en-US" sz="1400" i="1" dirty="0">
+              <a:rPr lang="en-US" sz="1700" i="1" dirty="0">
                 <a:solidFill>
                   <a:srgbClr val="FFFFFF">
                     <a:alpha val="70000"/>
@@ -15257,7 +15257,7 @@
               </a:rPr>
               <a:t>Come to L02 ready to help Sarah answer the question.</a:t>
             </a:r>
-            <a:endParaRPr lang="en-US" sz="1400" dirty="0"/>
+            <a:endParaRPr lang="en-US" sz="1700" dirty="0"/>
           </a:p>
         </p:txBody>
       </p:sp>
@@ -15343,7 +15343,7 @@
               <a:buNone/>
             </a:pPr>
             <a:r>
-              <a:rPr lang="en-US" sz="1600" b="1" dirty="0">
+              <a:rPr lang="en-US" sz="1700" b="1" dirty="0">
                 <a:solidFill>
                   <a:srgbClr val="FFFFFF"/>
                 </a:solidFill>
@@ -15353,7 +15353,7 @@
               </a:rPr>
               <a:t>Assignment Preview &amp; Q&amp;A</a:t>
             </a:r>
-            <a:endParaRPr lang="en-US" sz="1600" dirty="0"/>
+            <a:endParaRPr lang="en-US" sz="1700" dirty="0"/>
           </a:p>
         </p:txBody>
       </p:sp>
@@ -15615,7 +15615,7 @@
               <a:buNone/>
             </a:pPr>
             <a:r>
-              <a:rPr lang="en-US" sz="1500" b="1" dirty="0">
+              <a:rPr lang="en-US" sz="1700" b="1" dirty="0">
                 <a:solidFill>
                   <a:srgbClr val="1B2A4A"/>
                 </a:solidFill>
@@ -15625,7 +15625,7 @@
               </a:rPr>
               <a:t>Open: notebooks/assignment.ipynb</a:t>
             </a:r>
-            <a:endParaRPr lang="en-US" sz="1500" dirty="0"/>
+            <a:endParaRPr lang="en-US" sz="1700" dirty="0"/>
           </a:p>
         </p:txBody>
       </p:sp>
@@ -15657,7 +15657,7 @@
               <a:buNone/>
             </a:pPr>
             <a:r>
-              <a:rPr lang="en-US" sz="1500" dirty="0">
+              <a:rPr lang="en-US" sz="1700" dirty="0">
                 <a:solidFill>
                   <a:srgbClr val="333D4D"/>
                 </a:solidFill>
@@ -15674,7 +15674,7 @@
               <a:buNone/>
             </a:pPr>
             <a:r>
-              <a:rPr lang="en-US" sz="1500" b="1" dirty="0">
+              <a:rPr lang="en-US" sz="1700" b="1" dirty="0">
                 <a:solidFill>
                   <a:srgbClr val="1B2A4A"/>
                 </a:solidFill>
@@ -15692,7 +15692,7 @@
               <a:buNone/>
             </a:pPr>
             <a:r>
-              <a:rPr lang="en-US" sz="1500" dirty="0">
+              <a:rPr lang="en-US" sz="1700" dirty="0">
                 <a:solidFill>
                   <a:srgbClr val="333D4D"/>
                 </a:solidFill>
@@ -15710,7 +15710,7 @@
               <a:buNone/>
             </a:pPr>
             <a:r>
-              <a:rPr lang="en-US" sz="1500" dirty="0">
+              <a:rPr lang="en-US" sz="1700" dirty="0">
                 <a:solidFill>
                   <a:srgbClr val="333D4D"/>
                 </a:solidFill>
@@ -15728,7 +15728,7 @@
               <a:buNone/>
             </a:pPr>
             <a:r>
-              <a:rPr lang="en-US" sz="1500" dirty="0">
+              <a:rPr lang="en-US" sz="1700" dirty="0">
                 <a:solidFill>
                   <a:srgbClr val="333D4D"/>
                 </a:solidFill>
@@ -15745,7 +15745,7 @@
               <a:buNone/>
             </a:pPr>
             <a:r>
-              <a:rPr lang="en-US" sz="1500" b="1" dirty="0">
+              <a:rPr lang="en-US" sz="1700" b="1" dirty="0">
                 <a:solidFill>
                   <a:srgbClr val="1B2A4A"/>
                 </a:solidFill>
@@ -15763,7 +15763,7 @@
               <a:buNone/>
             </a:pPr>
             <a:r>
-              <a:rPr lang="en-US" sz="1500" dirty="0">
+              <a:rPr lang="en-US" sz="1700" dirty="0">
                 <a:solidFill>
                   <a:srgbClr val="333D4D"/>
                 </a:solidFill>
@@ -15773,7 +15773,7 @@
               </a:rPr>
               <a:t>•  Sample solutions at the bottom.</a:t>
             </a:r>
-            <a:endParaRPr lang="en-US" sz="1500" dirty="0"/>
+            <a:endParaRPr lang="en-US" sz="1700" dirty="0"/>
           </a:p>
         </p:txBody>
       </p:sp>
@@ -15930,7 +15930,7 @@
               <a:buNone/>
             </a:pPr>
             <a:r>
-              <a:rPr lang="en-US" sz="1500" b="1" dirty="0">
+              <a:rPr lang="en-US" sz="1700" b="1" dirty="0">
                 <a:solidFill>
                   <a:srgbClr val="1B2A4A"/>
                 </a:solidFill>
@@ -15940,7 +15940,7 @@
               </a:rPr>
               <a:t>Common questions:</a:t>
             </a:r>
-            <a:endParaRPr lang="en-US" sz="1500" dirty="0"/>
+            <a:endParaRPr lang="en-US" sz="1700" dirty="0"/>
           </a:p>
         </p:txBody>
       </p:sp>
@@ -15972,7 +15972,7 @@
               <a:buNone/>
             </a:pPr>
             <a:r>
-              <a:rPr lang="en-US" sz="1500" dirty="0">
+              <a:rPr lang="en-US" sz="1700" dirty="0">
                 <a:solidFill>
                   <a:srgbClr val="333D4D"/>
                 </a:solidFill>
@@ -15982,7 +15982,7 @@
               </a:rPr>
               <a:t>•  Why use a pre-trained model vs train your own?</a:t>
             </a:r>
-            <a:endParaRPr lang="en-US" sz="1500" dirty="0"/>
+            <a:endParaRPr lang="en-US" sz="1700" dirty="0"/>
           </a:p>
           <a:p>
             <a:pPr indent="0" marL="0">
@@ -15992,7 +15992,7 @@
               <a:buNone/>
             </a:pPr>
             <a:r>
-              <a:rPr lang="en-US" sz="1500" dirty="0">
+              <a:rPr lang="en-US" sz="1700" dirty="0">
                 <a:solidFill>
                   <a:srgbClr val="333D4D"/>
                 </a:solidFill>
@@ -16002,7 +16002,7 @@
               </a:rPr>
               <a:t>•  When should I trust the confidence score?</a:t>
             </a:r>
-            <a:endParaRPr lang="en-US" sz="1500" dirty="0"/>
+            <a:endParaRPr lang="en-US" sz="1700" dirty="0"/>
           </a:p>
           <a:p>
             <a:pPr indent="0" marL="0">
@@ -16012,7 +16012,7 @@
               <a:buNone/>
             </a:pPr>
             <a:r>
-              <a:rPr lang="en-US" sz="1500" dirty="0">
+              <a:rPr lang="en-US" sz="1700" dirty="0">
                 <a:solidFill>
                   <a:srgbClr val="333D4D"/>
                 </a:solidFill>
@@ -16022,7 +16022,7 @@
               </a:rPr>
               <a:t>•  What if my problem doesn't fit any of the three categories?</a:t>
             </a:r>
-            <a:endParaRPr lang="en-US" sz="1500" dirty="0"/>
+            <a:endParaRPr lang="en-US" sz="1700" dirty="0"/>
           </a:p>
           <a:p>
             <a:pPr indent="0" marL="0">
@@ -16032,7 +16032,7 @@
               <a:buNone/>
             </a:pPr>
             <a:r>
-              <a:rPr lang="en-US" sz="1500" dirty="0">
+              <a:rPr lang="en-US" sz="1700" dirty="0">
                 <a:solidFill>
                   <a:srgbClr val="333D4D"/>
                 </a:solidFill>
@@ -16042,7 +16042,7 @@
               </a:rPr>
               <a:t>•  Will we train neural networks in this course?</a:t>
             </a:r>
-            <a:endParaRPr lang="en-US" sz="1500" dirty="0"/>
+            <a:endParaRPr lang="en-US" sz="1700" dirty="0"/>
           </a:p>
         </p:txBody>
       </p:sp>
@@ -16167,7 +16167,7 @@
               <a:buNone/>
             </a:pPr>
             <a:r>
-              <a:rPr lang="en-US" sz="1600" b="1" dirty="0">
+              <a:rPr lang="en-US" sz="1700" b="1" dirty="0">
                 <a:solidFill>
                   <a:srgbClr val="FFFFFF"/>
                 </a:solidFill>
@@ -16177,7 +16177,7 @@
               </a:rPr>
               <a:t>The Shift in M3</a:t>
             </a:r>
-            <a:endParaRPr lang="en-US" sz="1600" dirty="0"/>
+            <a:endParaRPr lang="en-US" sz="1700" dirty="0"/>
           </a:p>
         </p:txBody>
       </p:sp>
@@ -16598,7 +16598,7 @@
               <a:buNone/>
             </a:pPr>
             <a:r>
-              <a:rPr lang="en-US" sz="1500" dirty="0">
+              <a:rPr lang="en-US" sz="1700" dirty="0">
                 <a:solidFill>
                   <a:srgbClr val="333D4D"/>
                 </a:solidFill>
@@ -16608,7 +16608,7 @@
               </a:rPr>
               <a:t>✓  Python · SQL · pandas · matplotlib · descriptive statistics</a:t>
             </a:r>
-            <a:endParaRPr lang="en-US" sz="1500" dirty="0"/>
+            <a:endParaRPr lang="en-US" sz="1700" dirty="0"/>
           </a:p>
           <a:p>
             <a:pPr indent="0" marL="0">
@@ -16618,7 +16618,7 @@
               <a:buNone/>
             </a:pPr>
             <a:r>
-              <a:rPr lang="en-US" sz="1500" dirty="0">
+              <a:rPr lang="en-US" sz="1700" dirty="0">
                 <a:solidFill>
                   <a:srgbClr val="333D4D"/>
                 </a:solidFill>
@@ -16628,7 +16628,7 @@
               </a:rPr>
               <a:t>✓  Reading data, joining tables, cleaning columns</a:t>
             </a:r>
-            <a:endParaRPr lang="en-US" sz="1500" dirty="0"/>
+            <a:endParaRPr lang="en-US" sz="1700" dirty="0"/>
           </a:p>
           <a:p>
             <a:pPr indent="0" marL="0">
@@ -16638,7 +16638,7 @@
               <a:buNone/>
             </a:pPr>
             <a:r>
-              <a:rPr lang="en-US" sz="1500" dirty="0">
+              <a:rPr lang="en-US" sz="1700" dirty="0">
                 <a:solidFill>
                   <a:srgbClr val="333D4D"/>
                 </a:solidFill>
@@ -16648,7 +16648,7 @@
               </a:rPr>
               <a:t>✓  Producing charts and dashboards that summarise the past</a:t>
             </a:r>
-            <a:endParaRPr lang="en-US" sz="1500" dirty="0"/>
+            <a:endParaRPr lang="en-US" sz="1700" dirty="0"/>
           </a:p>
         </p:txBody>
       </p:sp>
@@ -16766,7 +16766,7 @@
               <a:buNone/>
             </a:pPr>
             <a:r>
-              <a:rPr lang="en-US" sz="1500" b="1" dirty="0">
+              <a:rPr lang="en-US" sz="1700" b="1" dirty="0">
                 <a:solidFill>
                   <a:srgbClr val="C8102E"/>
                 </a:solidFill>
@@ -16780,7 +16780,7 @@
               <a:buNone/>
             </a:pPr>
             <a:r>
-              <a:rPr lang="en-US" sz="1500" dirty="0">
+              <a:rPr lang="en-US" sz="1700" dirty="0">
                 <a:solidFill>
                   <a:srgbClr val="333D4D"/>
                 </a:solidFill>
@@ -16795,7 +16795,7 @@
               <a:buNone/>
             </a:pPr>
             <a:r>
-              <a:rPr lang="en-US" sz="1500" b="1" dirty="0">
+              <a:rPr lang="en-US" sz="1700" b="1" dirty="0">
                 <a:solidFill>
                   <a:srgbClr val="C8102E"/>
                 </a:solidFill>
@@ -16809,7 +16809,7 @@
               <a:buNone/>
             </a:pPr>
             <a:r>
-              <a:rPr lang="en-US" sz="1500" dirty="0">
+              <a:rPr lang="en-US" sz="1700" dirty="0">
                 <a:solidFill>
                   <a:srgbClr val="333D4D"/>
                 </a:solidFill>
@@ -16819,7 +16819,7 @@
               </a:rPr>
               <a:t>A new vocabulary: training · inference · features · labels · supervised vs unsupervised.</a:t>
             </a:r>
-            <a:endParaRPr lang="en-US" sz="1500" dirty="0"/>
+            <a:endParaRPr lang="en-US" sz="1700" dirty="0"/>
           </a:p>
         </p:txBody>
       </p:sp>
@@ -16905,7 +16905,7 @@
               <a:buNone/>
             </a:pPr>
             <a:r>
-              <a:rPr lang="en-US" sz="1600" b="1" dirty="0">
+              <a:rPr lang="en-US" sz="1700" b="1" dirty="0">
                 <a:solidFill>
                   <a:srgbClr val="FFFFFF"/>
                 </a:solidFill>
@@ -16915,7 +16915,7 @@
               </a:rPr>
               <a:t>Meet Sarah Chen</a:t>
             </a:r>
-            <a:endParaRPr lang="en-US" sz="1600" dirty="0"/>
+            <a:endParaRPr lang="en-US" sz="1700" dirty="0"/>
           </a:p>
         </p:txBody>
       </p:sp>
@@ -17088,7 +17088,7 @@
               <a:buNone/>
             </a:pPr>
             <a:r>
-              <a:rPr lang="en-US" sz="1600" i="1" dirty="0">
+              <a:rPr lang="en-US" sz="1700" i="1" dirty="0">
                 <a:solidFill>
                   <a:srgbClr val="5F6B7A"/>
                 </a:solidFill>
@@ -17098,7 +17098,7 @@
               </a:rPr>
               <a:t>Customer Experience Analyst, NorthStar Retail — our protagonist for all of M3.</a:t>
             </a:r>
-            <a:endParaRPr lang="en-US" sz="1600" dirty="0"/>
+            <a:endParaRPr lang="en-US" sz="1700" dirty="0"/>
           </a:p>
         </p:txBody>
       </p:sp>
@@ -17280,7 +17280,7 @@
               <a:buNone/>
             </a:pPr>
             <a:r>
-              <a:rPr lang="en-US" sz="1400" dirty="0">
+              <a:rPr lang="en-US" sz="1700" dirty="0">
                 <a:solidFill>
                   <a:srgbClr val="333D4D"/>
                 </a:solidFill>
@@ -17290,7 +17290,7 @@
               </a:rPr>
               <a:t>Customer Experience Analyst</a:t>
             </a:r>
-            <a:endParaRPr lang="en-US" sz="1400" dirty="0"/>
+            <a:endParaRPr lang="en-US" sz="1700" dirty="0"/>
           </a:p>
         </p:txBody>
       </p:sp>
@@ -17712,7 +17712,7 @@
               <a:buNone/>
             </a:pPr>
             <a:r>
-              <a:rPr lang="en-US" sz="1600" b="1" dirty="0">
+              <a:rPr lang="en-US" sz="1700" b="1" dirty="0">
                 <a:solidFill>
                   <a:srgbClr val="FFFFFF"/>
                 </a:solidFill>
@@ -17722,7 +17722,7 @@
               </a:rPr>
               <a:t>The Scale Problem</a:t>
             </a:r>
-            <a:endParaRPr lang="en-US" sz="1600" dirty="0"/>
+            <a:endParaRPr lang="en-US" sz="1700" dirty="0"/>
           </a:p>
         </p:txBody>
       </p:sp>
@@ -18663,7 +18663,7 @@
               <a:buNone/>
             </a:pPr>
             <a:r>
-              <a:rPr lang="en-US" sz="1600" b="1" dirty="0">
+              <a:rPr lang="en-US" sz="1700" b="1" dirty="0">
                 <a:solidFill>
                   <a:srgbClr val="FFFFFF"/>
                 </a:solidFill>
@@ -18673,7 +18673,7 @@
               </a:rPr>
               <a:t>Approach 1: Rule-Based Programming</a:t>
             </a:r>
-            <a:endParaRPr lang="en-US" sz="1600" dirty="0"/>
+            <a:endParaRPr lang="en-US" sz="1700" dirty="0"/>
           </a:p>
         </p:txBody>
       </p:sp>
@@ -18960,7 +18960,7 @@
               <a:buNone/>
             </a:pPr>
             <a:r>
-              <a:rPr lang="en-US" sz="1400" b="1" dirty="0">
+              <a:rPr lang="en-US" sz="1700" b="1" dirty="0">
                 <a:solidFill>
                   <a:srgbClr val="FFFFFF"/>
                 </a:solidFill>
@@ -18970,7 +18970,7 @@
               </a:rPr>
               <a:t>1</a:t>
             </a:r>
-            <a:endParaRPr lang="en-US" sz="1400" dirty="0"/>
+            <a:endParaRPr lang="en-US" sz="1700" dirty="0"/>
           </a:p>
         </p:txBody>
       </p:sp>
@@ -18999,7 +18999,7 @@
               <a:buNone/>
             </a:pPr>
             <a:r>
-              <a:rPr lang="en-US" sz="1500" dirty="0">
+              <a:rPr lang="en-US" sz="1700" dirty="0">
                 <a:solidFill>
                   <a:srgbClr val="333D4D"/>
                 </a:solidFill>
@@ -19009,7 +19009,7 @@
               </a:rPr>
               <a:t>List positive words:  love, perfect, great, nice…</a:t>
             </a:r>
-            <a:endParaRPr lang="en-US" sz="1500" dirty="0"/>
+            <a:endParaRPr lang="en-US" sz="1700" dirty="0"/>
           </a:p>
         </p:txBody>
       </p:sp>
@@ -19063,7 +19063,7 @@
               <a:buNone/>
             </a:pPr>
             <a:r>
-              <a:rPr lang="en-US" sz="1400" b="1" dirty="0">
+              <a:rPr lang="en-US" sz="1700" b="1" dirty="0">
                 <a:solidFill>
                   <a:srgbClr val="FFFFFF"/>
                 </a:solidFill>
@@ -19073,7 +19073,7 @@
               </a:rPr>
               <a:t>2</a:t>
             </a:r>
-            <a:endParaRPr lang="en-US" sz="1400" dirty="0"/>
+            <a:endParaRPr lang="en-US" sz="1700" dirty="0"/>
           </a:p>
         </p:txBody>
       </p:sp>
@@ -19102,7 +19102,7 @@
               <a:buNone/>
             </a:pPr>
             <a:r>
-              <a:rPr lang="en-US" sz="1500" dirty="0">
+              <a:rPr lang="en-US" sz="1700" dirty="0">
                 <a:solidFill>
                   <a:srgbClr val="333D4D"/>
                 </a:solidFill>
@@ -19112,7 +19112,7 @@
               </a:rPr>
               <a:t>List negative words:  terrible, cheap, bad, awful…</a:t>
             </a:r>
-            <a:endParaRPr lang="en-US" sz="1500" dirty="0"/>
+            <a:endParaRPr lang="en-US" sz="1700" dirty="0"/>
           </a:p>
         </p:txBody>
       </p:sp>
@@ -19166,7 +19166,7 @@
               <a:buNone/>
             </a:pPr>
             <a:r>
-              <a:rPr lang="en-US" sz="1400" b="1" dirty="0">
+              <a:rPr lang="en-US" sz="1700" b="1" dirty="0">
                 <a:solidFill>
                   <a:srgbClr val="FFFFFF"/>
                 </a:solidFill>
@@ -19176,7 +19176,7 @@
               </a:rPr>
               <a:t>3</a:t>
             </a:r>
-            <a:endParaRPr lang="en-US" sz="1400" dirty="0"/>
+            <a:endParaRPr lang="en-US" sz="1700" dirty="0"/>
           </a:p>
         </p:txBody>
       </p:sp>
@@ -19205,7 +19205,7 @@
               <a:buNone/>
             </a:pPr>
             <a:r>
-              <a:rPr lang="en-US" sz="1500" dirty="0">
+              <a:rPr lang="en-US" sz="1700" dirty="0">
                 <a:solidFill>
                   <a:srgbClr val="333D4D"/>
                 </a:solidFill>
@@ -19215,7 +19215,7 @@
               </a:rPr>
               <a:t>For each review, count hits on each list.</a:t>
             </a:r>
-            <a:endParaRPr lang="en-US" sz="1500" dirty="0"/>
+            <a:endParaRPr lang="en-US" sz="1700" dirty="0"/>
           </a:p>
         </p:txBody>
       </p:sp>
@@ -19269,7 +19269,7 @@
               <a:buNone/>
             </a:pPr>
             <a:r>
-              <a:rPr lang="en-US" sz="1400" b="1" dirty="0">
+              <a:rPr lang="en-US" sz="1700" b="1" dirty="0">
                 <a:solidFill>
                   <a:srgbClr val="FFFFFF"/>
                 </a:solidFill>
@@ -19279,7 +19279,7 @@
               </a:rPr>
               <a:t>4</a:t>
             </a:r>
-            <a:endParaRPr lang="en-US" sz="1400" dirty="0"/>
+            <a:endParaRPr lang="en-US" sz="1700" dirty="0"/>
           </a:p>
         </p:txBody>
       </p:sp>
@@ -19308,7 +19308,7 @@
               <a:buNone/>
             </a:pPr>
             <a:r>
-              <a:rPr lang="en-US" sz="1500" dirty="0">
+              <a:rPr lang="en-US" sz="1700" dirty="0">
                 <a:solidFill>
                   <a:srgbClr val="333D4D"/>
                 </a:solidFill>
@@ -19318,7 +19318,7 @@
               </a:rPr>
               <a:t>Whichever count is bigger wins.</a:t>
             </a:r>
-            <a:endParaRPr lang="en-US" sz="1500" dirty="0"/>
+            <a:endParaRPr lang="en-US" sz="1700" dirty="0"/>
           </a:p>
         </p:txBody>
       </p:sp>
@@ -19475,7 +19475,7 @@
               <a:buNone/>
             </a:pPr>
             <a:r>
-              <a:rPr lang="en-US" sz="1500" dirty="0">
+              <a:rPr lang="en-US" sz="1700" dirty="0">
                 <a:solidFill>
                   <a:srgbClr val="333D4D"/>
                 </a:solidFill>
@@ -19485,7 +19485,7 @@
               </a:rPr>
               <a:t>You write the rules</a:t>
             </a:r>
-            <a:endParaRPr lang="en-US" sz="1500" dirty="0"/>
+            <a:endParaRPr lang="en-US" sz="1700" dirty="0"/>
           </a:p>
         </p:txBody>
       </p:sp>
@@ -19553,7 +19553,7 @@
               <a:buNone/>
             </a:pPr>
             <a:r>
-              <a:rPr lang="en-US" sz="1500" dirty="0">
+              <a:rPr lang="en-US" sz="1700" dirty="0">
                 <a:solidFill>
                   <a:srgbClr val="333D4D"/>
                 </a:solidFill>
@@ -19563,7 +19563,7 @@
               </a:rPr>
               <a:t>Computer follows them exactly</a:t>
             </a:r>
-            <a:endParaRPr lang="en-US" sz="1500" dirty="0"/>
+            <a:endParaRPr lang="en-US" sz="1700" dirty="0"/>
           </a:p>
         </p:txBody>
       </p:sp>
@@ -19631,7 +19631,7 @@
               <a:buNone/>
             </a:pPr>
             <a:r>
-              <a:rPr lang="en-US" sz="1500" dirty="0">
+              <a:rPr lang="en-US" sz="1700" dirty="0">
                 <a:solidFill>
                   <a:srgbClr val="333D4D"/>
                 </a:solidFill>
@@ -19641,7 +19641,7 @@
               </a:rPr>
               <a:t>Deterministic — same input, same output</a:t>
             </a:r>
-            <a:endParaRPr lang="en-US" sz="1500" dirty="0"/>
+            <a:endParaRPr lang="en-US" sz="1700" dirty="0"/>
           </a:p>
         </p:txBody>
       </p:sp>
@@ -19709,7 +19709,7 @@
               <a:buNone/>
             </a:pPr>
             <a:r>
-              <a:rPr lang="en-US" sz="1500" dirty="0">
+              <a:rPr lang="en-US" sz="1700" dirty="0">
                 <a:solidFill>
                   <a:srgbClr val="5F6B7A"/>
                 </a:solidFill>
@@ -19719,7 +19719,7 @@
               </a:rPr>
               <a:t>Only handles cases the rules covered</a:t>
             </a:r>
-            <a:endParaRPr lang="en-US" sz="1500" dirty="0"/>
+            <a:endParaRPr lang="en-US" sz="1700" dirty="0"/>
           </a:p>
         </p:txBody>
       </p:sp>
@@ -19787,7 +19787,7 @@
               <a:buNone/>
             </a:pPr>
             <a:r>
-              <a:rPr lang="en-US" sz="1500" dirty="0">
+              <a:rPr lang="en-US" sz="1700" dirty="0">
                 <a:solidFill>
                   <a:srgbClr val="5F6B7A"/>
                 </a:solidFill>
@@ -19797,7 +19797,7 @@
               </a:rPr>
               <a:t>Maintenance is whack-a-mole</a:t>
             </a:r>
-            <a:endParaRPr lang="en-US" sz="1500" dirty="0"/>
+            <a:endParaRPr lang="en-US" sz="1700" dirty="0"/>
           </a:p>
         </p:txBody>
       </p:sp>
@@ -19865,7 +19865,7 @@
               <a:buNone/>
             </a:pPr>
             <a:r>
-              <a:rPr lang="en-US" sz="1500" dirty="0">
+              <a:rPr lang="en-US" sz="1700" dirty="0">
                 <a:solidFill>
                   <a:srgbClr val="5F6B7A"/>
                 </a:solidFill>
@@ -19875,7 +19875,7 @@
               </a:rPr>
               <a:t>No notion of ‘confidence’</a:t>
             </a:r>
-            <a:endParaRPr lang="en-US" sz="1500" dirty="0"/>
+            <a:endParaRPr lang="en-US" sz="1700" dirty="0"/>
           </a:p>
         </p:txBody>
       </p:sp>
@@ -19961,7 +19961,7 @@
               <a:buNone/>
             </a:pPr>
             <a:r>
-              <a:rPr lang="en-US" sz="1600" b="1" dirty="0">
+              <a:rPr lang="en-US" sz="1700" b="1" dirty="0">
                 <a:solidFill>
                   <a:srgbClr val="FFFFFF"/>
                 </a:solidFill>
@@ -19971,7 +19971,7 @@
               </a:rPr>
               <a:t>Rule-Based Code</a:t>
             </a:r>
-            <a:endParaRPr lang="en-US" sz="1600" dirty="0"/>
+            <a:endParaRPr lang="en-US" sz="1700" dirty="0"/>
           </a:p>
         </p:txBody>
       </p:sp>
@@ -20127,8 +20127,8 @@
         </p:nvSpPr>
         <p:spPr>
           <a:xfrm>
-            <a:off x="548640" y="2011680"/>
-            <a:ext cx="11091672" cy="3474720"/>
+            <a:off x="548640" y="1874520"/>
+            <a:ext cx="11091672" cy="4297680"/>
           </a:xfrm>
           <a:prstGeom prst="rect">
             <a:avLst/>
@@ -20152,8 +20152,8 @@
         </p:nvSpPr>
         <p:spPr>
           <a:xfrm>
-            <a:off x="548640" y="2011680"/>
-            <a:ext cx="54864" cy="3474720"/>
+            <a:off x="548640" y="1874520"/>
+            <a:ext cx="54864" cy="4297680"/>
           </a:xfrm>
           <a:prstGeom prst="rect">
             <a:avLst/>
@@ -20177,7 +20177,7 @@
         </p:nvSpPr>
         <p:spPr>
           <a:xfrm>
-            <a:off x="10543032" y="2148840"/>
+            <a:off x="10543032" y="2011680"/>
             <a:ext cx="914400" cy="274320"/>
           </a:xfrm>
           <a:prstGeom prst="rect">
@@ -20216,8 +20216,8 @@
         </p:nvSpPr>
         <p:spPr>
           <a:xfrm>
-            <a:off x="914400" y="2331720"/>
-            <a:ext cx="10543032" cy="3017520"/>
+            <a:off x="914400" y="2194560"/>
+            <a:ext cx="10543032" cy="3840480"/>
           </a:xfrm>
           <a:prstGeom prst="rect">
             <a:avLst/>
@@ -20233,7 +20233,7 @@
               <a:buNone/>
             </a:pPr>
             <a:r>
-              <a:rPr lang="en-US" sz="1450" dirty="0">
+              <a:rPr lang="en-US" sz="1700" dirty="0">
                 <a:solidFill>
                   <a:srgbClr val="FFFFFF"/>
                 </a:solidFill>
@@ -20243,14 +20243,14 @@
               </a:rPr>
               <a:t>positive_words = ["love", "perfect", "great", "nice", "soft"]</a:t>
             </a:r>
-            <a:endParaRPr lang="en-US" sz="1450" dirty="0"/>
-          </a:p>
-          <a:p>
-            <a:pPr indent="0" marL="0">
-              <a:buNone/>
-            </a:pPr>
-            <a:r>
-              <a:rPr lang="en-US" sz="1450" dirty="0">
+            <a:endParaRPr lang="en-US" sz="1700" dirty="0"/>
+          </a:p>
+          <a:p>
+            <a:pPr indent="0" marL="0">
+              <a:buNone/>
+            </a:pPr>
+            <a:r>
+              <a:rPr lang="en-US" sz="1700" dirty="0">
                 <a:solidFill>
                   <a:srgbClr val="FFFFFF"/>
                 </a:solidFill>
@@ -20260,20 +20260,20 @@
               </a:rPr>
               <a:t>negative_words = ["terrible", "cheap", "disappointed", "bad", "late"]</a:t>
             </a:r>
-            <a:endParaRPr lang="en-US" sz="1450" dirty="0"/>
-          </a:p>
-          <a:p>
-            <a:pPr indent="0" marL="0">
-              <a:buNone/>
-            </a:pPr>
-            <a:endParaRPr lang="en-US" sz="1450" dirty="0"/>
-          </a:p>
-          <a:p>
-            <a:pPr indent="0" marL="0">
-              <a:buNone/>
-            </a:pPr>
-            <a:r>
-              <a:rPr lang="en-US" sz="1450" dirty="0">
+            <a:endParaRPr lang="en-US" sz="1700" dirty="0"/>
+          </a:p>
+          <a:p>
+            <a:pPr indent="0" marL="0">
+              <a:buNone/>
+            </a:pPr>
+            <a:endParaRPr lang="en-US" sz="1700" dirty="0"/>
+          </a:p>
+          <a:p>
+            <a:pPr indent="0" marL="0">
+              <a:buNone/>
+            </a:pPr>
+            <a:r>
+              <a:rPr lang="en-US" sz="1700" dirty="0">
                 <a:solidFill>
                   <a:srgbClr val="FFFFFF"/>
                 </a:solidFill>
@@ -20283,14 +20283,14 @@
               </a:rPr>
               <a:t>def rule_based_sentiment(review):</a:t>
             </a:r>
-            <a:endParaRPr lang="en-US" sz="1450" dirty="0"/>
-          </a:p>
-          <a:p>
-            <a:pPr indent="0" marL="0">
-              <a:buNone/>
-            </a:pPr>
-            <a:r>
-              <a:rPr lang="en-US" sz="1450" dirty="0">
+            <a:endParaRPr lang="en-US" sz="1700" dirty="0"/>
+          </a:p>
+          <a:p>
+            <a:pPr indent="0" marL="0">
+              <a:buNone/>
+            </a:pPr>
+            <a:r>
+              <a:rPr lang="en-US" sz="1700" dirty="0">
                 <a:solidFill>
                   <a:srgbClr val="FFFFFF"/>
                 </a:solidFill>
@@ -20300,14 +20300,14 @@
               </a:rPr>
               <a:t>    text = review.lower()</a:t>
             </a:r>
-            <a:endParaRPr lang="en-US" sz="1450" dirty="0"/>
-          </a:p>
-          <a:p>
-            <a:pPr indent="0" marL="0">
-              <a:buNone/>
-            </a:pPr>
-            <a:r>
-              <a:rPr lang="en-US" sz="1450" dirty="0">
+            <a:endParaRPr lang="en-US" sz="1700" dirty="0"/>
+          </a:p>
+          <a:p>
+            <a:pPr indent="0" marL="0">
+              <a:buNone/>
+            </a:pPr>
+            <a:r>
+              <a:rPr lang="en-US" sz="1700" dirty="0">
                 <a:solidFill>
                   <a:srgbClr val="FFFFFF"/>
                 </a:solidFill>
@@ -20317,14 +20317,14 @@
               </a:rPr>
               <a:t>    pos_hits = sum(1 for w in positive_words if w in text)</a:t>
             </a:r>
-            <a:endParaRPr lang="en-US" sz="1450" dirty="0"/>
-          </a:p>
-          <a:p>
-            <a:pPr indent="0" marL="0">
-              <a:buNone/>
-            </a:pPr>
-            <a:r>
-              <a:rPr lang="en-US" sz="1450" dirty="0">
+            <a:endParaRPr lang="en-US" sz="1700" dirty="0"/>
+          </a:p>
+          <a:p>
+            <a:pPr indent="0" marL="0">
+              <a:buNone/>
+            </a:pPr>
+            <a:r>
+              <a:rPr lang="en-US" sz="1700" dirty="0">
                 <a:solidFill>
                   <a:srgbClr val="FFFFFF"/>
                 </a:solidFill>
@@ -20334,14 +20334,14 @@
               </a:rPr>
               <a:t>    neg_hits = sum(1 for w in negative_words if w in text)</a:t>
             </a:r>
-            <a:endParaRPr lang="en-US" sz="1450" dirty="0"/>
-          </a:p>
-          <a:p>
-            <a:pPr indent="0" marL="0">
-              <a:buNone/>
-            </a:pPr>
-            <a:r>
-              <a:rPr lang="en-US" sz="1450" dirty="0">
+            <a:endParaRPr lang="en-US" sz="1700" dirty="0"/>
+          </a:p>
+          <a:p>
+            <a:pPr indent="0" marL="0">
+              <a:buNone/>
+            </a:pPr>
+            <a:r>
+              <a:rPr lang="en-US" sz="1700" dirty="0">
                 <a:solidFill>
                   <a:srgbClr val="FFFFFF"/>
                 </a:solidFill>
@@ -20351,14 +20351,14 @@
               </a:rPr>
               <a:t>    if pos_hits &gt; neg_hits:   return "POSITIVE"</a:t>
             </a:r>
-            <a:endParaRPr lang="en-US" sz="1450" dirty="0"/>
-          </a:p>
-          <a:p>
-            <a:pPr indent="0" marL="0">
-              <a:buNone/>
-            </a:pPr>
-            <a:r>
-              <a:rPr lang="en-US" sz="1450" dirty="0">
+            <a:endParaRPr lang="en-US" sz="1700" dirty="0"/>
+          </a:p>
+          <a:p>
+            <a:pPr indent="0" marL="0">
+              <a:buNone/>
+            </a:pPr>
+            <a:r>
+              <a:rPr lang="en-US" sz="1700" dirty="0">
                 <a:solidFill>
                   <a:srgbClr val="FFFFFF"/>
                 </a:solidFill>
@@ -20368,14 +20368,14 @@
               </a:rPr>
               <a:t>    elif neg_hits &gt; pos_hits: return "NEGATIVE"</a:t>
             </a:r>
-            <a:endParaRPr lang="en-US" sz="1450" dirty="0"/>
-          </a:p>
-          <a:p>
-            <a:pPr indent="0" marL="0">
-              <a:buNone/>
-            </a:pPr>
-            <a:r>
-              <a:rPr lang="en-US" sz="1450" dirty="0">
+            <a:endParaRPr lang="en-US" sz="1700" dirty="0"/>
+          </a:p>
+          <a:p>
+            <a:pPr indent="0" marL="0">
+              <a:buNone/>
+            </a:pPr>
+            <a:r>
+              <a:rPr lang="en-US" sz="1700" dirty="0">
                 <a:solidFill>
                   <a:srgbClr val="FFFFFF"/>
                 </a:solidFill>
@@ -20385,20 +20385,20 @@
               </a:rPr>
               <a:t>    else:                     return "NEUTRAL"</a:t>
             </a:r>
-            <a:endParaRPr lang="en-US" sz="1450" dirty="0"/>
-          </a:p>
-          <a:p>
-            <a:pPr indent="0" marL="0">
-              <a:buNone/>
-            </a:pPr>
-            <a:endParaRPr lang="en-US" sz="1450" dirty="0"/>
-          </a:p>
-          <a:p>
-            <a:pPr indent="0" marL="0">
-              <a:buNone/>
-            </a:pPr>
-            <a:r>
-              <a:rPr lang="en-US" sz="1450" dirty="0">
+            <a:endParaRPr lang="en-US" sz="1700" dirty="0"/>
+          </a:p>
+          <a:p>
+            <a:pPr indent="0" marL="0">
+              <a:buNone/>
+            </a:pPr>
+            <a:endParaRPr lang="en-US" sz="1700" dirty="0"/>
+          </a:p>
+          <a:p>
+            <a:pPr indent="0" marL="0">
+              <a:buNone/>
+            </a:pPr>
+            <a:r>
+              <a:rPr lang="en-US" sz="1700" dirty="0">
                 <a:solidFill>
                   <a:srgbClr val="FFFFFF"/>
                 </a:solidFill>
@@ -20408,14 +20408,14 @@
               </a:rPr>
               <a:t>for r in reviews:</a:t>
             </a:r>
-            <a:endParaRPr lang="en-US" sz="1450" dirty="0"/>
-          </a:p>
-          <a:p>
-            <a:pPr indent="0" marL="0">
-              <a:buNone/>
-            </a:pPr>
-            <a:r>
-              <a:rPr lang="en-US" sz="1450" dirty="0">
+            <a:endParaRPr lang="en-US" sz="1700" dirty="0"/>
+          </a:p>
+          <a:p>
+            <a:pPr indent="0" marL="0">
+              <a:buNone/>
+            </a:pPr>
+            <a:r>
+              <a:rPr lang="en-US" sz="1700" dirty="0">
                 <a:solidFill>
                   <a:srgbClr val="FFFFFF"/>
                 </a:solidFill>
@@ -20425,7 +20425,7 @@
               </a:rPr>
               <a:t>    print(f"{rule_based_sentiment(r):&gt;9} | {r}")</a:t>
             </a:r>
-            <a:endParaRPr lang="en-US" sz="1450" dirty="0"/>
+            <a:endParaRPr lang="en-US" sz="1700" dirty="0"/>
           </a:p>
         </p:txBody>
       </p:sp>
@@ -20437,8 +20437,8 @@
         </p:nvSpPr>
         <p:spPr>
           <a:xfrm>
-            <a:off x="548640" y="5669280"/>
-            <a:ext cx="11091672" cy="777240"/>
+            <a:off x="548640" y="6355080"/>
+            <a:ext cx="11091672" cy="502920"/>
           </a:xfrm>
           <a:prstGeom prst="rect">
             <a:avLst/>
@@ -20462,8 +20462,8 @@
         </p:nvSpPr>
         <p:spPr>
           <a:xfrm>
-            <a:off x="548640" y="5669280"/>
-            <a:ext cx="45720" cy="777240"/>
+            <a:off x="548640" y="6355080"/>
+            <a:ext cx="45720" cy="502920"/>
           </a:xfrm>
           <a:prstGeom prst="rect">
             <a:avLst/>
@@ -20487,8 +20487,8 @@
         </p:nvSpPr>
         <p:spPr>
           <a:xfrm>
-            <a:off x="822960" y="5715000"/>
-            <a:ext cx="10543032" cy="685800"/>
+            <a:off x="822960" y="6382512"/>
+            <a:ext cx="10543032" cy="457200"/>
           </a:xfrm>
           <a:prstGeom prst="rect">
             <a:avLst/>
@@ -20504,7 +20504,7 @@
               <a:buNone/>
             </a:pPr>
             <a:r>
-              <a:rPr lang="en-US" sz="1500" b="1" spc="500" kern="0" dirty="0">
+              <a:rPr lang="en-US" sz="1300" b="1" spc="500" kern="0" dirty="0">
                 <a:solidFill>
                   <a:srgbClr val="C8102E"/>
                 </a:solidFill>
@@ -20518,7 +20518,7 @@
               <a:buNone/>
             </a:pPr>
             <a:r>
-              <a:rPr lang="en-US" sz="1500" dirty="0">
+              <a:rPr lang="en-US" sz="1300" dirty="0">
                 <a:solidFill>
                   <a:srgbClr val="5F6B7A"/>
                 </a:solidFill>
@@ -20532,7 +20532,7 @@
               <a:buNone/>
             </a:pPr>
             <a:r>
-              <a:rPr lang="en-US" sz="1500" b="1" i="1" dirty="0">
+              <a:rPr lang="en-US" sz="1300" b="1" i="1" dirty="0">
                 <a:solidFill>
                   <a:srgbClr val="1B2A4A"/>
                 </a:solidFill>
@@ -20546,7 +20546,7 @@
               <a:buNone/>
             </a:pPr>
             <a:r>
-              <a:rPr lang="en-US" sz="1500" dirty="0">
+              <a:rPr lang="en-US" sz="1300" dirty="0">
                 <a:solidFill>
                   <a:srgbClr val="5F6B7A"/>
                 </a:solidFill>
@@ -20556,7 +20556,7 @@
               </a:rPr>
               <a:t>  ?</a:t>
             </a:r>
-            <a:endParaRPr lang="en-US" sz="1500" dirty="0"/>
+            <a:endParaRPr lang="en-US" sz="1300" dirty="0"/>
           </a:p>
         </p:txBody>
       </p:sp>
@@ -20642,7 +20642,7 @@
               <a:buNone/>
             </a:pPr>
             <a:r>
-              <a:rPr lang="en-US" sz="1600" b="1" dirty="0">
+              <a:rPr lang="en-US" sz="1700" b="1" dirty="0">
                 <a:solidFill>
                   <a:srgbClr val="FFFFFF"/>
                 </a:solidFill>
@@ -20652,7 +20652,7 @@
               </a:rPr>
               <a:t>Why Rule-Based Fails</a:t>
             </a:r>
-            <a:endParaRPr lang="en-US" sz="1600" dirty="0"/>
+            <a:endParaRPr lang="en-US" sz="1700" dirty="0"/>
           </a:p>
         </p:txBody>
       </p:sp>
@@ -20953,7 +20953,7 @@
               <a:buNone/>
             </a:pPr>
             <a:r>
-              <a:rPr lang="en-US" sz="1400" i="1" dirty="0">
+              <a:rPr lang="en-US" sz="1700" i="1" dirty="0">
                 <a:solidFill>
                   <a:srgbClr val="1B2A4A"/>
                 </a:solidFill>
@@ -20963,7 +20963,7 @@
               </a:rPr>
               <a:t>“Terrible shipping — product itself is fine.”</a:t>
             </a:r>
-            <a:endParaRPr lang="en-US" sz="1400" dirty="0"/>
+            <a:endParaRPr lang="en-US" sz="1700" dirty="0"/>
           </a:p>
         </p:txBody>
       </p:sp>
@@ -21223,7 +21223,7 @@
               <a:buNone/>
             </a:pPr>
             <a:r>
-              <a:rPr lang="en-US" sz="1400" i="1" dirty="0">
+              <a:rPr lang="en-US" sz="1700" i="1" dirty="0">
                 <a:solidFill>
                   <a:srgbClr val="1B2A4A"/>
                 </a:solidFill>
@@ -21233,7 +21233,7 @@
               </a:rPr>
               <a:t>“Not what I expected — actually really nice in person!”</a:t>
             </a:r>
-            <a:endParaRPr lang="en-US" sz="1400" dirty="0"/>
+            <a:endParaRPr lang="en-US" sz="1700" dirty="0"/>
           </a:p>
         </p:txBody>
       </p:sp>
@@ -21493,7 +21493,7 @@
               <a:buNone/>
             </a:pPr>
             <a:r>
-              <a:rPr lang="en-US" sz="1400" i="1" dirty="0">
+              <a:rPr lang="en-US" sz="1700" i="1" dirty="0">
                 <a:solidFill>
                   <a:srgbClr val="1B2A4A"/>
                 </a:solidFill>
@@ -21503,7 +21503,7 @@
               </a:rPr>
               <a:t>Every new review surfaces a new edge case.</a:t>
             </a:r>
-            <a:endParaRPr lang="en-US" sz="1400" dirty="0"/>
+            <a:endParaRPr lang="en-US" sz="1700" dirty="0"/>
           </a:p>
         </p:txBody>
       </p:sp>
@@ -21692,7 +21692,7 @@
               <a:buNone/>
             </a:pPr>
             <a:r>
-              <a:rPr lang="en-US" sz="1600" b="1" dirty="0">
+              <a:rPr lang="en-US" sz="1700" b="1" dirty="0">
                 <a:solidFill>
                   <a:srgbClr val="FFFFFF"/>
                 </a:solidFill>
@@ -21702,7 +21702,7 @@
               </a:rPr>
               <a:t>Approach 2: Machine Learning</a:t>
             </a:r>
-            <a:endParaRPr lang="en-US" sz="1600" dirty="0"/>
+            <a:endParaRPr lang="en-US" sz="1700" dirty="0"/>
           </a:p>
         </p:txBody>
       </p:sp>
@@ -22023,7 +22023,7 @@
               <a:buNone/>
             </a:pPr>
             <a:r>
-              <a:rPr lang="en-US" sz="1500" b="1" spc="500" kern="0" dirty="0">
+              <a:rPr lang="en-US" sz="1700" b="1" spc="500" kern="0" dirty="0">
                 <a:solidFill>
                   <a:srgbClr val="2C5697"/>
                 </a:solidFill>
@@ -22040,7 +22040,7 @@
               <a:buNone/>
             </a:pPr>
             <a:r>
-              <a:rPr lang="en-US" sz="1500" dirty="0">
+              <a:rPr lang="en-US" sz="1700" dirty="0">
                 <a:solidFill>
                   <a:srgbClr val="333D4D"/>
                 </a:solidFill>
@@ -22058,7 +22058,7 @@
               <a:buNone/>
             </a:pPr>
             <a:r>
-              <a:rPr lang="en-US" sz="1500" b="1" spc="500" kern="0" dirty="0">
+              <a:rPr lang="en-US" sz="1700" b="1" spc="500" kern="0" dirty="0">
                 <a:solidFill>
                   <a:srgbClr val="2C5697"/>
                 </a:solidFill>
@@ -22075,7 +22075,7 @@
               <a:buNone/>
             </a:pPr>
             <a:r>
-              <a:rPr lang="en-US" sz="1500" dirty="0">
+              <a:rPr lang="en-US" sz="1700" dirty="0">
                 <a:solidFill>
                   <a:srgbClr val="333D4D"/>
                 </a:solidFill>
@@ -22085,7 +22085,7 @@
               </a:rPr>
               <a:t>deterministic answer</a:t>
             </a:r>
-            <a:endParaRPr lang="en-US" sz="1500" dirty="0"/>
+            <a:endParaRPr lang="en-US" sz="1700" dirty="0"/>
           </a:p>
         </p:txBody>
       </p:sp>
@@ -22262,7 +22262,7 @@
               <a:buNone/>
             </a:pPr>
             <a:r>
-              <a:rPr lang="en-US" sz="1500" b="1" spc="500" kern="0" dirty="0">
+              <a:rPr lang="en-US" sz="1700" b="1" spc="500" kern="0" dirty="0">
                 <a:solidFill>
                   <a:srgbClr val="C8102E"/>
                 </a:solidFill>
@@ -22279,7 +22279,7 @@
               <a:buNone/>
             </a:pPr>
             <a:r>
-              <a:rPr lang="en-US" sz="1500" dirty="0">
+              <a:rPr lang="en-US" sz="1700" dirty="0">
                 <a:solidFill>
                   <a:srgbClr val="333D4D"/>
                 </a:solidFill>
@@ -22297,7 +22297,7 @@
               <a:buNone/>
             </a:pPr>
             <a:r>
-              <a:rPr lang="en-US" sz="1500" b="1" spc="500" kern="0" dirty="0">
+              <a:rPr lang="en-US" sz="1700" b="1" spc="500" kern="0" dirty="0">
                 <a:solidFill>
                   <a:srgbClr val="C8102E"/>
                 </a:solidFill>
@@ -22314,7 +22314,7 @@
               <a:buNone/>
             </a:pPr>
             <a:r>
-              <a:rPr lang="en-US" sz="1500" dirty="0">
+              <a:rPr lang="en-US" sz="1700" dirty="0">
                 <a:solidFill>
                   <a:srgbClr val="333D4D"/>
                 </a:solidFill>
@@ -22324,7 +22324,7 @@
               </a:rPr>
               <a:t>prediction + confidence</a:t>
             </a:r>
-            <a:endParaRPr lang="en-US" sz="1500" dirty="0"/>
+            <a:endParaRPr lang="en-US" sz="1700" dirty="0"/>
           </a:p>
         </p:txBody>
       </p:sp>

</xml_diff>